<commit_message>
Slide 5 : part de voix 15,6 % et courbe mise à jour
Co-Authored-By: Claude Opus 5.5 <noreply@anthropic.com>
Claude-Session: https://claude.ai/code/session_014FKzAw3xP1tDY13CjjrvxH
</commit_message>
<xml_diff>
--- a/20261001_Rapport_Boulanger_Hebdo.pptx
+++ b/20261001_Rapport_Boulanger_Hebdo.pptx
@@ -198,9 +198,9 @@
           </c:dLbls>
           <c:cat>
             <c:strRef>
-              <c:f>Sheet1!$A$2:$A$7</c:f>
+              <c:f>Sheet1!$A$2:$A$8</c:f>
               <c:strCache>
-                <c:ptCount val="6"/>
+                <c:ptCount val="7"/>
                 <c:pt idx="0">
                   <c:v>11 sept.</c:v>
                 </c:pt>
@@ -219,15 +219,18 @@
                 <c:pt idx="5">
                   <c:v>1er oct.</c:v>
                 </c:pt>
+                <c:pt idx="6">
+                  <c:v>8 oct.</c:v>
+                </c:pt>
               </c:strCache>
             </c:strRef>
           </c:cat>
           <c:val>
             <c:numRef>
-              <c:f>Sheet1!$B$2:$B$7</c:f>
+              <c:f>Sheet1!$B$2:$B$8</c:f>
               <c:numCache>
                 <c:formatCode>General</c:formatCode>
-                <c:ptCount val="6"/>
+                <c:ptCount val="7"/>
                 <c:pt idx="0">
                   <c:v>13.4</c:v>
                 </c:pt>
@@ -245,6 +248,9 @@
                 </c:pt>
                 <c:pt idx="5">
                   <c:v>15.3</c:v>
+                </c:pt>
+                <c:pt idx="6">
+                  <c:v>15.6</c:v>
                 </c:pt>
               </c:numCache>
             </c:numRef>
@@ -296,9 +302,9 @@
           </c:dLbls>
           <c:cat>
             <c:strRef>
-              <c:f>Sheet1!$A$2:$A$7</c:f>
+              <c:f>Sheet1!$A$2:$A$8</c:f>
               <c:strCache>
-                <c:ptCount val="6"/>
+                <c:ptCount val="7"/>
                 <c:pt idx="0">
                   <c:v>11 sept.</c:v>
                 </c:pt>
@@ -317,15 +323,18 @@
                 <c:pt idx="5">
                   <c:v>1er oct.</c:v>
                 </c:pt>
+                <c:pt idx="6">
+                  <c:v>8 oct.</c:v>
+                </c:pt>
               </c:strCache>
             </c:strRef>
           </c:cat>
           <c:val>
             <c:numRef>
-              <c:f>Sheet1!$C$2:$C$7</c:f>
+              <c:f>Sheet1!$C$2:$C$8</c:f>
               <c:numCache>
                 <c:formatCode>General</c:formatCode>
-                <c:ptCount val="6"/>
+                <c:ptCount val="7"/>
                 <c:pt idx="0">
                   <c:v>15.5</c:v>
                 </c:pt>
@@ -338,11 +347,17 @@
                 <c:pt idx="3">
                   <c:v>15.3</c:v>
                 </c:pt>
+                <c:pt idx="6">
+                  <c:v>15.6</c:v>
+                </c:pt>
                 <c:pt idx="4">
                   <c:v>15.5</c:v>
                 </c:pt>
                 <c:pt idx="5">
                   <c:v>15.7</c:v>
+                </c:pt>
+                <c:pt idx="6">
+                  <c:v>15.8</c:v>
                 </c:pt>
               </c:numCache>
             </c:numRef>
@@ -15050,7 +15065,7 @@
                 </a:solidFill>
                 <a:latin typeface="Inter"/>
               </a:rPr>
-              <a:t> part de voix de 15,3 %, soit </a:t>
+              <a:t> part de voix de 15,6 %, soit </a:t>
             </a:r>
             <a:r>
               <a:rPr sz="850" b="1" i="0">
@@ -15059,7 +15074,7 @@
                 </a:solidFill>
                 <a:latin typeface="Inter"/>
               </a:rPr>
-              <a:t>+0,5 point</a:t>
+              <a:t>+0,3 point</a:t>
             </a:r>
             <a:r>
               <a:rPr sz="850" b="0" i="0">
@@ -15068,7 +15083,7 @@
                 </a:solidFill>
                 <a:latin typeface="Inter"/>
               </a:rPr>
-              <a:t> vs S-1 (14,8 %)</a:t>
+              <a:t> vs S-1 (15,3 %)</a:t>
             </a:r>
           </a:p>
         </p:txBody>
@@ -15270,7 +15285,7 @@
                 </a:solidFill>
                 <a:latin typeface="Inter"/>
               </a:rPr>
-              <a:t>20,4 %</a:t>
+              <a:t>20,2 %</a:t>
             </a:r>
           </a:p>
         </p:txBody>
@@ -15402,7 +15417,7 @@
         <p:spPr>
           <a:xfrm>
             <a:off x="3337560" y="3200400"/>
-            <a:ext cx="2439968" cy="64008"/>
+            <a:ext cx="2477028" cy="64008"/>
           </a:xfrm>
           <a:prstGeom prst="roundRect">
             <a:avLst>
@@ -15472,7 +15487,7 @@
                 </a:solidFill>
                 <a:latin typeface="Inter"/>
               </a:rPr>
-              <a:t>19,1 %</a:t>
+              <a:t>19,2 %</a:t>
             </a:r>
           </a:p>
         </p:txBody>
@@ -15604,7 +15619,7 @@
         <p:spPr>
           <a:xfrm>
             <a:off x="3337560" y="3520440"/>
-            <a:ext cx="1954530" cy="64008"/>
+            <a:ext cx="2012585" cy="64008"/>
           </a:xfrm>
           <a:prstGeom prst="roundRect">
             <a:avLst>
@@ -15674,7 +15689,7 @@
                 </a:solidFill>
                 <a:latin typeface="Inter"/>
               </a:rPr>
-              <a:t>15,3 %</a:t>
+              <a:t>15,6 %</a:t>
             </a:r>
           </a:p>
         </p:txBody>
@@ -15806,7 +15821,7 @@
         <p:spPr>
           <a:xfrm>
             <a:off x="3337560" y="3840480"/>
-            <a:ext cx="1814008" cy="64008"/>
+            <a:ext cx="1819067" cy="64008"/>
           </a:xfrm>
           <a:prstGeom prst="roundRect">
             <a:avLst>
@@ -15876,7 +15891,7 @@
                 </a:solidFill>
                 <a:latin typeface="Inter"/>
               </a:rPr>
-              <a:t>14,2 %</a:t>
+              <a:t>14,1 %</a:t>
             </a:r>
           </a:p>
         </p:txBody>
@@ -16008,7 +16023,7 @@
         <p:spPr>
           <a:xfrm>
             <a:off x="3337560" y="4160520"/>
-            <a:ext cx="1226371" cy="64008"/>
+            <a:ext cx="1251415" cy="64008"/>
           </a:xfrm>
           <a:prstGeom prst="roundRect">
             <a:avLst>
@@ -16078,7 +16093,7 @@
                 </a:solidFill>
                 <a:latin typeface="Inter"/>
               </a:rPr>
-              <a:t>9,6 %</a:t>
+              <a:t>9,7 %</a:t>
             </a:r>
           </a:p>
         </p:txBody>
@@ -16210,7 +16225,7 @@
         <p:spPr>
           <a:xfrm>
             <a:off x="3337560" y="4480560"/>
-            <a:ext cx="1124174" cy="64008"/>
+            <a:ext cx="1096600" cy="64008"/>
           </a:xfrm>
           <a:prstGeom prst="roundRect">
             <a:avLst>
@@ -16280,7 +16295,7 @@
                 </a:solidFill>
                 <a:latin typeface="Inter"/>
               </a:rPr>
-              <a:t>8,8 %</a:t>
+              <a:t>8,5 %</a:t>
             </a:r>
           </a:p>
         </p:txBody>
@@ -16412,7 +16427,7 @@
         <p:spPr>
           <a:xfrm>
             <a:off x="3337560" y="4800600"/>
-            <a:ext cx="702608" cy="64008"/>
+            <a:ext cx="722466" cy="64008"/>
           </a:xfrm>
           <a:prstGeom prst="roundRect">
             <a:avLst>
@@ -16482,7 +16497,7 @@
                 </a:solidFill>
                 <a:latin typeface="Inter"/>
               </a:rPr>
-              <a:t>5,5 %</a:t>
+              <a:t>5,6 %</a:t>
             </a:r>
           </a:p>
         </p:txBody>
@@ -16614,7 +16629,7 @@
         <p:spPr>
           <a:xfrm>
             <a:off x="3337560" y="5120640"/>
-            <a:ext cx="523762" cy="64008"/>
+            <a:ext cx="503146" cy="64008"/>
           </a:xfrm>
           <a:prstGeom prst="roundRect">
             <a:avLst>
@@ -16684,7 +16699,7 @@
                 </a:solidFill>
                 <a:latin typeface="Inter"/>
               </a:rPr>
-              <a:t>4,1 %</a:t>
+              <a:t>3,9 %</a:t>
             </a:r>
           </a:p>
         </p:txBody>
@@ -16816,7 +16831,7 @@
         <p:spPr>
           <a:xfrm>
             <a:off x="3337560" y="5440680"/>
-            <a:ext cx="383241" cy="64008"/>
+            <a:ext cx="399936" cy="64008"/>
           </a:xfrm>
           <a:prstGeom prst="roundRect">
             <a:avLst>
@@ -16886,7 +16901,7 @@
                 </a:solidFill>
                 <a:latin typeface="Inter"/>
               </a:rPr>
-              <a:t>3,0 %</a:t>
+              <a:t>3,1 %</a:t>
             </a:r>
           </a:p>
         </p:txBody>
@@ -17088,7 +17103,7 @@
                 </a:solidFill>
                 <a:latin typeface="Inter"/>
               </a:rPr>
-              <a:t>0,0 %</a:t>
+              <a:t>0,1 %</a:t>
             </a:r>
           </a:p>
         </p:txBody>

</xml_diff>

<commit_message>
Slide 6 : win rate 22,9 %, carte comparaison retirée
Co-Authored-By: Claude Opus 5.5 <noreply@anthropic.com>
Claude-Session: https://claude.ai/code/session_014FKzAw3xP1tDY13CjjrvxH
</commit_message>
<xml_diff>
--- a/20261001_Rapport_Boulanger_Hebdo.pptx
+++ b/20261001_Rapport_Boulanger_Hebdo.pptx
@@ -4683,7 +4683,7 @@
                 </a:solidFill>
                 <a:latin typeface="Inter"/>
               </a:rPr>
-              <a:t>Le win rate progresse, mais reste à 22,5 % : dans trois comparaisons sur quatre, l'utilisateur clique ailleurs.</a:t>
+              <a:t>Le win rate progresse, mais reste à 22,9 % : dans trois comparaisons sur quatre, l'utilisateur clique ailleurs.</a:t>
             </a:r>
           </a:p>
         </p:txBody>
@@ -4834,7 +4834,7 @@
                 </a:solidFill>
                 <a:latin typeface="Inter"/>
               </a:rPr>
-              <a:t>Quand Boulanger est comparé à une enseigne, l'utilisateur clique sur l'annonce Boulanger dans 22,5 % des cas.</a:t>
+              <a:t>Quand Boulanger est comparé à une enseigne, l'utilisateur clique sur l'annonce Boulanger dans 22,9 % des cas.</a:t>
             </a:r>
           </a:p>
         </p:txBody>
@@ -17567,7 +17567,7 @@
         <p:spPr>
           <a:xfrm>
             <a:off x="457200" y="1325880"/>
-            <a:ext cx="2697480" cy="2468880"/>
+            <a:ext cx="5513832" cy="2468880"/>
           </a:xfrm>
           <a:prstGeom prst="rect">
             <a:avLst/>
@@ -17614,7 +17614,7 @@
         <p:spPr>
           <a:xfrm>
             <a:off x="713232" y="1563624"/>
-            <a:ext cx="2185416" cy="320040"/>
+            <a:ext cx="4965192" cy="320040"/>
           </a:xfrm>
           <a:prstGeom prst="rect">
             <a:avLst/>
@@ -17648,7 +17648,7 @@
         <p:spPr>
           <a:xfrm>
             <a:off x="713232" y="1929384"/>
-            <a:ext cx="2185416" cy="548640"/>
+            <a:ext cx="4965192" cy="548640"/>
           </a:xfrm>
           <a:prstGeom prst="rect">
             <a:avLst/>
@@ -17668,7 +17668,7 @@
                 </a:solidFill>
                 <a:latin typeface="Inter"/>
               </a:rPr>
-              <a:t>22,5 %</a:t>
+              <a:t>22,9 %</a:t>
             </a:r>
           </a:p>
         </p:txBody>
@@ -17682,7 +17682,7 @@
         <p:spPr>
           <a:xfrm>
             <a:off x="713232" y="2569464"/>
-            <a:ext cx="2185416" cy="256032"/>
+            <a:ext cx="4965192" cy="256032"/>
           </a:xfrm>
           <a:prstGeom prst="rect">
             <a:avLst/>
@@ -17702,7 +17702,7 @@
                 </a:solidFill>
                 <a:latin typeface="Inter"/>
               </a:rPr>
-              <a:t>▲ +0,2 pt</a:t>
+              <a:t>▲ +0,4 pt</a:t>
             </a:r>
             <a:r>
               <a:rPr sz="900" b="0" i="0">
@@ -17725,7 +17725,7 @@
         <p:spPr>
           <a:xfrm>
             <a:off x="713232" y="2953512"/>
-            <a:ext cx="2185416" cy="685800"/>
+            <a:ext cx="4965192" cy="685800"/>
           </a:xfrm>
           <a:prstGeom prst="rect">
             <a:avLst/>
@@ -17745,199 +17745,7 @@
                 </a:solidFill>
                 <a:latin typeface="Inter"/>
               </a:rPr>
-              <a:t>Quand l'IA compare Boulanger à une autre enseigne, dans combien de cas l'utilisateur clique sur l'annonce Boulanger ? Base semaine précédente : 22,3 %.</a:t>
-            </a:r>
-          </a:p>
-        </p:txBody>
-      </p:sp>
-      <p:sp>
-        <p:nvSpPr>
-          <p:cNvPr id="13" name="Rectangle 12"/>
-          <p:cNvSpPr/>
-          <p:nvPr/>
-        </p:nvSpPr>
-        <p:spPr>
-          <a:xfrm>
-            <a:off x="3246120" y="1325880"/>
-            <a:ext cx="2724912" cy="2468880"/>
-          </a:xfrm>
-          <a:prstGeom prst="rect">
-            <a:avLst/>
-          </a:prstGeom>
-          <a:solidFill>
-            <a:srgbClr val="FFFFFF"/>
-          </a:solidFill>
-          <a:ln w="10160">
-            <a:solidFill>
-              <a:srgbClr val="ECEBE7"/>
-            </a:solidFill>
-          </a:ln>
-          <a:effectLst/>
-        </p:spPr>
-        <p:style>
-          <a:lnRef idx="1">
-            <a:schemeClr val="accent1"/>
-          </a:lnRef>
-          <a:fillRef idx="3">
-            <a:schemeClr val="accent1"/>
-          </a:fillRef>
-          <a:effectRef idx="2">
-            <a:schemeClr val="accent1"/>
-          </a:effectRef>
-          <a:fontRef idx="minor">
-            <a:schemeClr val="lt1"/>
-          </a:fontRef>
-        </p:style>
-        <p:txBody>
-          <a:bodyPr wrap="square" rtlCol="0" anchor="ctr"/>
-          <a:lstStyle/>
-          <a:p>
-            <a:pPr algn="ctr"/>
-            <a:endParaRPr/>
-          </a:p>
-        </p:txBody>
-      </p:sp>
-      <p:sp>
-        <p:nvSpPr>
-          <p:cNvPr id="14" name="TextBox 13"/>
-          <p:cNvSpPr txBox="1"/>
-          <p:nvPr/>
-        </p:nvSpPr>
-        <p:spPr>
-          <a:xfrm>
-            <a:off x="3502152" y="1563624"/>
-            <a:ext cx="2212848" cy="320040"/>
-          </a:xfrm>
-          <a:prstGeom prst="rect">
-            <a:avLst/>
-          </a:prstGeom>
-          <a:noFill/>
-        </p:spPr>
-        <p:txBody>
-          <a:bodyPr wrap="square" lIns="0" tIns="0" rIns="0" bIns="0">
-            <a:spAutoFit/>
-          </a:bodyPr>
-          <a:lstStyle/>
-          <a:p>
-            <a:r>
-              <a:rPr sz="750" b="1" i="0" spc="150">
-                <a:solidFill>
-                  <a:srgbClr val="6B6B6B"/>
-                </a:solidFill>
-                <a:latin typeface="Inter"/>
-              </a:rPr>
-              <a:t>BOULANGER EST-IL COMPARÉ À UN CONCURRENT ?</a:t>
-            </a:r>
-          </a:p>
-        </p:txBody>
-      </p:sp>
-      <p:sp>
-        <p:nvSpPr>
-          <p:cNvPr id="15" name="TextBox 14"/>
-          <p:cNvSpPr txBox="1"/>
-          <p:nvPr/>
-        </p:nvSpPr>
-        <p:spPr>
-          <a:xfrm>
-            <a:off x="3502152" y="1929384"/>
-            <a:ext cx="2212848" cy="548640"/>
-          </a:xfrm>
-          <a:prstGeom prst="rect">
-            <a:avLst/>
-          </a:prstGeom>
-          <a:noFill/>
-        </p:spPr>
-        <p:txBody>
-          <a:bodyPr wrap="square" lIns="0" tIns="0" rIns="0" bIns="0">
-            <a:spAutoFit/>
-          </a:bodyPr>
-          <a:lstStyle/>
-          <a:p>
-            <a:r>
-              <a:rPr sz="3000" b="1" i="0">
-                <a:solidFill>
-                  <a:srgbClr val="F26B2A"/>
-                </a:solidFill>
-                <a:latin typeface="Inter"/>
-              </a:rPr>
-              <a:t>46,5 %</a:t>
-            </a:r>
-          </a:p>
-        </p:txBody>
-      </p:sp>
-      <p:sp>
-        <p:nvSpPr>
-          <p:cNvPr id="16" name="TextBox 15"/>
-          <p:cNvSpPr txBox="1"/>
-          <p:nvPr/>
-        </p:nvSpPr>
-        <p:spPr>
-          <a:xfrm>
-            <a:off x="3502152" y="2569464"/>
-            <a:ext cx="2212848" cy="256032"/>
-          </a:xfrm>
-          <a:prstGeom prst="rect">
-            <a:avLst/>
-          </a:prstGeom>
-          <a:noFill/>
-        </p:spPr>
-        <p:txBody>
-          <a:bodyPr wrap="square" lIns="0" tIns="0" rIns="0" bIns="0">
-            <a:spAutoFit/>
-          </a:bodyPr>
-          <a:lstStyle/>
-          <a:p>
-            <a:r>
-              <a:rPr sz="1250" b="1" i="0">
-                <a:solidFill>
-                  <a:srgbClr val="196B24"/>
-                </a:solidFill>
-                <a:latin typeface="Inter"/>
-              </a:rPr>
-              <a:t>▲ +0,5 pt</a:t>
-            </a:r>
-            <a:r>
-              <a:rPr sz="900" b="0" i="0">
-                <a:solidFill>
-                  <a:srgbClr val="6B6B6B"/>
-                </a:solidFill>
-                <a:latin typeface="Inter"/>
-              </a:rPr>
-              <a:t>  vs 17→23/09</a:t>
-            </a:r>
-          </a:p>
-        </p:txBody>
-      </p:sp>
-      <p:sp>
-        <p:nvSpPr>
-          <p:cNvPr id="17" name="TextBox 16"/>
-          <p:cNvSpPr txBox="1"/>
-          <p:nvPr/>
-        </p:nvSpPr>
-        <p:spPr>
-          <a:xfrm>
-            <a:off x="3502152" y="2953512"/>
-            <a:ext cx="2212848" cy="685800"/>
-          </a:xfrm>
-          <a:prstGeom prst="rect">
-            <a:avLst/>
-          </a:prstGeom>
-          <a:noFill/>
-        </p:spPr>
-        <p:txBody>
-          <a:bodyPr wrap="square" lIns="0" tIns="0" rIns="0" bIns="0">
-            <a:spAutoFit/>
-          </a:bodyPr>
-          <a:lstStyle/>
-          <a:p>
-            <a:r>
-              <a:rPr sz="850" b="0" i="0">
-                <a:solidFill>
-                  <a:srgbClr val="6B6B6B"/>
-                </a:solidFill>
-                <a:latin typeface="Inter"/>
-              </a:rPr>
-              <a:t>Part des réponses qui présentent Boulanger comme une option face à une autre enseigne. Base semaine précédente : 46,0 %. Valeur projetée.</a:t>
+              <a:t>Quand l'IA compare Boulanger à une autre enseigne, dans combien de cas l'utilisateur clique sur l'annonce Boulanger ? Base semaine précédente : 22,5 %.</a:t>
             </a:r>
           </a:p>
         </p:txBody>

</xml_diff>

<commit_message>
Slide 6 : moment d'apparition 55/29/16
Co-Authored-By: Claude Opus 5.5 <noreply@anthropic.com>
Claude-Session: https://claude.ai/code/session_014FKzAw3xP1tDY13CjjrvxH
</commit_message>
<xml_diff>
--- a/20261001_Rapport_Boulanger_Hebdo.pptx
+++ b/20261001_Rapport_Boulanger_Hebdo.pptx
@@ -17860,7 +17860,7 @@
                 </a:solidFill>
                 <a:latin typeface="Inter"/>
               </a:rPr>
-              <a:t>Dans les conversations où Boulanger est cité, l'IA le mentionne pour la première fois dès sa première réponse dans 53 % des cas, au deuxième échange dans 30 % des cas, et plus tard dans 17 % des cas. Valeurs projetées.</a:t>
+              <a:t>Dans les conversations où Boulanger est cité, l'IA le mentionne pour la première fois dès sa première réponse dans 55 % des cas, au deuxième échange dans 29 % des cas, et plus tard dans 16 % des cas. Valeurs projetées.</a:t>
             </a:r>
           </a:p>
         </p:txBody>
@@ -17874,7 +17874,7 @@
         <p:spPr>
           <a:xfrm>
             <a:off x="731520" y="5166359"/>
-            <a:ext cx="2602473" cy="457200"/>
+            <a:ext cx="2700665" cy="457200"/>
           </a:xfrm>
           <a:prstGeom prst="rect">
             <a:avLst/>
@@ -17921,7 +17921,7 @@
         <p:spPr>
           <a:xfrm>
             <a:off x="731520" y="5166359"/>
-            <a:ext cx="2602473" cy="457200"/>
+            <a:ext cx="2700665" cy="457200"/>
           </a:xfrm>
           <a:prstGeom prst="rect">
             <a:avLst/>
@@ -17942,7 +17942,7 @@
                 </a:solidFill>
                 <a:latin typeface="Inter"/>
               </a:rPr>
-              <a:t>53 %</a:t>
+              <a:t>55 %</a:t>
             </a:r>
           </a:p>
         </p:txBody>
@@ -17989,8 +17989,8 @@
         </p:nvSpPr>
         <p:spPr>
           <a:xfrm>
-            <a:off x="3361425" y="5166359"/>
-            <a:ext cx="1473098" cy="457200"/>
+            <a:off x="3459617" y="5166359"/>
+            <a:ext cx="1423987" cy="457200"/>
           </a:xfrm>
           <a:prstGeom prst="rect">
             <a:avLst/>
@@ -18036,8 +18036,8 @@
         </p:nvSpPr>
         <p:spPr>
           <a:xfrm>
-            <a:off x="3361425" y="5166359"/>
-            <a:ext cx="1473098" cy="457200"/>
+            <a:off x="3459617" y="5166359"/>
+            <a:ext cx="1423987" cy="457200"/>
           </a:xfrm>
           <a:prstGeom prst="rect">
             <a:avLst/>
@@ -18058,7 +18058,7 @@
                 </a:solidFill>
                 <a:latin typeface="Inter"/>
               </a:rPr>
-              <a:t>30 %</a:t>
+              <a:t>29 %</a:t>
             </a:r>
           </a:p>
         </p:txBody>
@@ -18071,7 +18071,7 @@
         </p:nvSpPr>
         <p:spPr>
           <a:xfrm>
-            <a:off x="3361425" y="5715000"/>
+            <a:off x="3459617" y="5715000"/>
             <a:ext cx="1619402" cy="182880"/>
           </a:xfrm>
           <a:prstGeom prst="rect">
@@ -18105,8 +18105,8 @@
         </p:nvSpPr>
         <p:spPr>
           <a:xfrm>
-            <a:off x="4861956" y="5166359"/>
-            <a:ext cx="834755" cy="457200"/>
+            <a:off x="4911036" y="5166359"/>
+            <a:ext cx="785675" cy="457200"/>
           </a:xfrm>
           <a:prstGeom prst="rect">
             <a:avLst/>
@@ -18152,8 +18152,8 @@
         </p:nvSpPr>
         <p:spPr>
           <a:xfrm>
-            <a:off x="4861956" y="5166359"/>
-            <a:ext cx="834755" cy="457200"/>
+            <a:off x="4911036" y="5166359"/>
+            <a:ext cx="785675" cy="457200"/>
           </a:xfrm>
           <a:prstGeom prst="rect">
             <a:avLst/>
@@ -18174,7 +18174,7 @@
                 </a:solidFill>
                 <a:latin typeface="Inter"/>
               </a:rPr>
-              <a:t>17 %</a:t>
+              <a:t>16 %</a:t>
             </a:r>
           </a:p>
         </p:txBody>

</xml_diff>

<commit_message>
Slides 6, 7, 9, 10 : comparaisons alignées sur la part de voix, top 10 intentions mis à jour
Co-Authored-By: Claude Opus 5.5 <noreply@anthropic.com>
Claude-Session: https://claude.ai/code/session_014FKzAw3xP1tDY13CjjrvxH
</commit_message>
<xml_diff>
--- a/20261001_Rapport_Boulanger_Hebdo.pptx
+++ b/20261001_Rapport_Boulanger_Hebdo.pptx
@@ -5417,7 +5417,7 @@
                 </a:solidFill>
                 <a:latin typeface="Inter"/>
               </a:rPr>
-              <a:t>Casque et écouteurs · 5,4 %</a:t>
+              <a:t>Casque et écouteurs · 5,3 %</a:t>
             </a:r>
           </a:p>
         </p:txBody>
@@ -5501,7 +5501,7 @@
                 </a:solidFill>
                 <a:latin typeface="Inter"/>
               </a:rPr>
-              <a:t>Enceinte portable · 5,0 %</a:t>
+              <a:t>Enceinte portable · 5,1 %</a:t>
             </a:r>
           </a:p>
         </p:txBody>
@@ -18393,7 +18393,7 @@
                 </a:solidFill>
                 <a:latin typeface="Inter"/>
               </a:rPr>
-              <a:t>vs Back Market</a:t>
+              <a:t>vs E.Leclerc</a:t>
             </a:r>
           </a:p>
         </p:txBody>
@@ -18456,7 +18456,7 @@
         <p:spPr>
           <a:xfrm>
             <a:off x="7772400" y="2542032"/>
-            <a:ext cx="2340864" cy="128016"/>
+            <a:ext cx="2926080" cy="128016"/>
           </a:xfrm>
           <a:prstGeom prst="roundRect">
             <a:avLst>
@@ -18526,7 +18526,7 @@
                 </a:solidFill>
                 <a:latin typeface="Inter"/>
               </a:rPr>
-              <a:t>16 %</a:t>
+              <a:t>20 %</a:t>
             </a:r>
           </a:p>
         </p:txBody>
@@ -18560,7 +18560,7 @@
                 </a:solidFill>
                 <a:latin typeface="Inter"/>
               </a:rPr>
-              <a:t>vs Auchan</a:t>
+              <a:t>vs Amazon</a:t>
             </a:r>
           </a:p>
         </p:txBody>
@@ -18623,7 +18623,7 @@
         <p:spPr>
           <a:xfrm>
             <a:off x="7772400" y="2980944"/>
-            <a:ext cx="2194560" cy="128016"/>
+            <a:ext cx="2779776" cy="128016"/>
           </a:xfrm>
           <a:prstGeom prst="roundRect">
             <a:avLst>
@@ -18693,7 +18693,7 @@
                 </a:solidFill>
                 <a:latin typeface="Inter"/>
               </a:rPr>
-              <a:t>15 %</a:t>
+              <a:t>19 %</a:t>
             </a:r>
           </a:p>
         </p:txBody>
@@ -18727,7 +18727,7 @@
                 </a:solidFill>
                 <a:latin typeface="Inter"/>
               </a:rPr>
-              <a:t>vs Darty</a:t>
+              <a:t>vs Carrefour</a:t>
             </a:r>
           </a:p>
         </p:txBody>
@@ -18790,7 +18790,7 @@
         <p:spPr>
           <a:xfrm>
             <a:off x="7772400" y="3419856"/>
-            <a:ext cx="1901952" cy="128016"/>
+            <a:ext cx="2194560" cy="128016"/>
           </a:xfrm>
           <a:prstGeom prst="roundRect">
             <a:avLst>
@@ -18860,7 +18860,7 @@
                 </a:solidFill>
                 <a:latin typeface="Inter"/>
               </a:rPr>
-              <a:t>13 %</a:t>
+              <a:t>15 %</a:t>
             </a:r>
           </a:p>
         </p:txBody>
@@ -18894,7 +18894,7 @@
                 </a:solidFill>
                 <a:latin typeface="Inter"/>
               </a:rPr>
-              <a:t>vs Carrefour</a:t>
+              <a:t>vs Auchan</a:t>
             </a:r>
           </a:p>
         </p:txBody>
@@ -18957,7 +18957,7 @@
         <p:spPr>
           <a:xfrm>
             <a:off x="7772400" y="3858768"/>
-            <a:ext cx="1901952" cy="128016"/>
+            <a:ext cx="1755648" cy="128016"/>
           </a:xfrm>
           <a:prstGeom prst="roundRect">
             <a:avLst>
@@ -18965,11 +18965,11 @@
             </a:avLst>
           </a:prstGeom>
           <a:solidFill>
-            <a:srgbClr val="F26B2A"/>
+            <a:srgbClr val="F6D8C2"/>
           </a:solidFill>
           <a:ln w="12700">
             <a:solidFill>
-              <a:srgbClr val="F26B2A"/>
+              <a:srgbClr val="F6D8C2"/>
             </a:solidFill>
           </a:ln>
           <a:effectLst/>
@@ -19023,11 +19023,11 @@
             <a:r>
               <a:rPr sz="1000" b="1" i="0">
                 <a:solidFill>
-                  <a:srgbClr val="F26B2A"/>
-                </a:solidFill>
-                <a:latin typeface="Inter"/>
-              </a:rPr>
-              <a:t>13 %</a:t>
+                  <a:srgbClr val="0A0A0A"/>
+                </a:solidFill>
+                <a:latin typeface="Inter"/>
+              </a:rPr>
+              <a:t>12 %</a:t>
             </a:r>
           </a:p>
         </p:txBody>
@@ -19061,7 +19061,7 @@
                 </a:solidFill>
                 <a:latin typeface="Inter"/>
               </a:rPr>
-              <a:t>vs E.Leclerc</a:t>
+              <a:t>vs Cdiscount</a:t>
             </a:r>
           </a:p>
         </p:txBody>
@@ -19124,7 +19124,7 @@
         <p:spPr>
           <a:xfrm>
             <a:off x="7772400" y="4297680"/>
-            <a:ext cx="1755648" cy="128016"/>
+            <a:ext cx="1609344" cy="128016"/>
           </a:xfrm>
           <a:prstGeom prst="roundRect">
             <a:avLst>
@@ -19194,7 +19194,7 @@
                 </a:solidFill>
                 <a:latin typeface="Inter"/>
               </a:rPr>
-              <a:t>12 %</a:t>
+              <a:t>11 %</a:t>
             </a:r>
           </a:p>
         </p:txBody>
@@ -19228,7 +19228,7 @@
                 </a:solidFill>
                 <a:latin typeface="Inter"/>
               </a:rPr>
-              <a:t>vs Fnac</a:t>
+              <a:t>vs Darty</a:t>
             </a:r>
           </a:p>
         </p:txBody>
@@ -19291,7 +19291,7 @@
         <p:spPr>
           <a:xfrm>
             <a:off x="7772400" y="4736592"/>
-            <a:ext cx="1755648" cy="128016"/>
+            <a:ext cx="1316736" cy="128016"/>
           </a:xfrm>
           <a:prstGeom prst="roundRect">
             <a:avLst>
@@ -19361,7 +19361,7 @@
                 </a:solidFill>
                 <a:latin typeface="Inter"/>
               </a:rPr>
-              <a:t>12 %</a:t>
+              <a:t>9 %</a:t>
             </a:r>
           </a:p>
         </p:txBody>
@@ -19395,7 +19395,7 @@
                 </a:solidFill>
                 <a:latin typeface="Inter"/>
               </a:rPr>
-              <a:t>vs Cdiscount</a:t>
+              <a:t>vs Back Market</a:t>
             </a:r>
           </a:p>
         </p:txBody>
@@ -19458,7 +19458,7 @@
         <p:spPr>
           <a:xfrm>
             <a:off x="7772400" y="5175503"/>
-            <a:ext cx="1609344" cy="128016"/>
+            <a:ext cx="1170432" cy="128016"/>
           </a:xfrm>
           <a:prstGeom prst="roundRect">
             <a:avLst>
@@ -19528,7 +19528,7 @@
                 </a:solidFill>
                 <a:latin typeface="Inter"/>
               </a:rPr>
-              <a:t>11 %</a:t>
+              <a:t>8 %</a:t>
             </a:r>
           </a:p>
         </p:txBody>
@@ -19562,7 +19562,7 @@
                 </a:solidFill>
                 <a:latin typeface="Inter"/>
               </a:rPr>
-              <a:t>vs Amazon</a:t>
+              <a:t>vs Fnac</a:t>
             </a:r>
           </a:p>
         </p:txBody>
@@ -19625,7 +19625,7 @@
         <p:spPr>
           <a:xfrm>
             <a:off x="7772400" y="5614416"/>
-            <a:ext cx="1170432" cy="128016"/>
+            <a:ext cx="877824" cy="128016"/>
           </a:xfrm>
           <a:prstGeom prst="roundRect">
             <a:avLst>
@@ -19695,7 +19695,7 @@
                 </a:solidFill>
                 <a:latin typeface="Inter"/>
               </a:rPr>
-              <a:t>8 %</a:t>
+              <a:t>6 %</a:t>
             </a:r>
           </a:p>
         </p:txBody>
@@ -19821,7 +19821,7 @@
                 </a:solidFill>
                 <a:latin typeface="Inter"/>
               </a:rPr>
-              <a:t>Back Market concentre 16 % des comparaisons, soit deux fois Amazon (8 %). Répartition indicative, projetée : ce ne sont pas des résultats mesurés.</a:t>
+              <a:t>E.Leclerc et Amazon, leaders en part de voix, pèsent 39 % des comparaisons. Répartition indicative, projetée, non mesurée.</a:t>
             </a:r>
           </a:p>
         </p:txBody>
@@ -21059,7 +21059,7 @@
                 </a:solidFill>
                 <a:latin typeface="Inter"/>
               </a:rPr>
-              <a:t>5,4 %</a:t>
+              <a:t>5,3 %</a:t>
             </a:r>
           </a:p>
         </p:txBody>
@@ -21161,7 +21161,7 @@
                 </a:solidFill>
                 <a:latin typeface="Inter"/>
               </a:rPr>
-              <a:t>3,2 %</a:t>
+              <a:t>3,3 %</a:t>
             </a:r>
           </a:p>
         </p:txBody>
@@ -21478,7 +21478,7 @@
                 </a:solidFill>
                 <a:latin typeface="Inter"/>
               </a:rPr>
-              <a:t>5,0 %</a:t>
+              <a:t>5,1 %</a:t>
             </a:r>
           </a:p>
         </p:txBody>
@@ -21580,7 +21580,7 @@
                 </a:solidFill>
                 <a:latin typeface="Inter"/>
               </a:rPr>
-              <a:t>2,9 %</a:t>
+              <a:t>3,0 %</a:t>
             </a:r>
           </a:p>
         </p:txBody>
@@ -21897,7 +21897,7 @@
                 </a:solidFill>
                 <a:latin typeface="Inter"/>
               </a:rPr>
-              <a:t>4,6 %</a:t>
+              <a:t>4,7 %</a:t>
             </a:r>
           </a:p>
         </p:txBody>
@@ -21999,7 +21999,7 @@
                 </a:solidFill>
                 <a:latin typeface="Inter"/>
               </a:rPr>
-              <a:t>3,1 %</a:t>
+              <a:t>3,0 %</a:t>
             </a:r>
           </a:p>
         </p:txBody>
@@ -22316,7 +22316,7 @@
                 </a:solidFill>
                 <a:latin typeface="Inter"/>
               </a:rPr>
-              <a:t>4,3 %</a:t>
+              <a:t>4,4 %</a:t>
             </a:r>
           </a:p>
         </p:txBody>
@@ -22418,7 +22418,7 @@
                 </a:solidFill>
                 <a:latin typeface="Inter"/>
               </a:rPr>
-              <a:t>2,5 %</a:t>
+              <a:t>2,6 %</a:t>
             </a:r>
           </a:p>
         </p:txBody>
@@ -22680,7 +22680,7 @@
         </p:nvSpPr>
         <p:spPr>
           <a:xfrm>
-            <a:off x="457200" y="3938016"/>
+            <a:off x="457200" y="4602480"/>
             <a:ext cx="201168" cy="182880"/>
           </a:xfrm>
           <a:prstGeom prst="rect">
@@ -22701,7 +22701,7 @@
                 </a:solidFill>
                 <a:latin typeface="Inter"/>
               </a:rPr>
-              <a:t>6</a:t>
+              <a:t>8</a:t>
             </a:r>
           </a:p>
         </p:txBody>
@@ -22714,7 +22714,7 @@
         </p:nvSpPr>
         <p:spPr>
           <a:xfrm>
-            <a:off x="731520" y="3919728"/>
+            <a:off x="731520" y="4584192"/>
             <a:ext cx="2011680" cy="329184"/>
           </a:xfrm>
           <a:prstGeom prst="rect">
@@ -22748,7 +22748,7 @@
         </p:nvSpPr>
         <p:spPr>
           <a:xfrm>
-            <a:off x="2788920" y="3919728"/>
+            <a:off x="2788920" y="4584192"/>
             <a:ext cx="548640" cy="201168"/>
           </a:xfrm>
           <a:prstGeom prst="rect">
@@ -22769,7 +22769,7 @@
                 </a:solidFill>
                 <a:latin typeface="Inter"/>
               </a:rPr>
-              <a:t>4,0 %</a:t>
+              <a:t>3,7 %</a:t>
             </a:r>
           </a:p>
         </p:txBody>
@@ -22782,7 +22782,7 @@
         </p:nvSpPr>
         <p:spPr>
           <a:xfrm>
-            <a:off x="3429000" y="3919728"/>
+            <a:off x="3429000" y="4584192"/>
             <a:ext cx="2834640" cy="329184"/>
           </a:xfrm>
           <a:prstGeom prst="rect">
@@ -22816,7 +22816,7 @@
         </p:nvSpPr>
         <p:spPr>
           <a:xfrm>
-            <a:off x="6355080" y="3919728"/>
+            <a:off x="6355080" y="4584192"/>
             <a:ext cx="1965960" cy="329184"/>
           </a:xfrm>
           <a:prstGeom prst="rect">
@@ -22850,7 +22850,7 @@
         </p:nvSpPr>
         <p:spPr>
           <a:xfrm>
-            <a:off x="8412480" y="3919728"/>
+            <a:off x="8412480" y="4584192"/>
             <a:ext cx="822960" cy="201168"/>
           </a:xfrm>
           <a:prstGeom prst="rect">
@@ -22871,7 +22871,7 @@
                 </a:solidFill>
                 <a:latin typeface="Inter"/>
               </a:rPr>
-              <a:t>2,0 %</a:t>
+              <a:t>2,1 %</a:t>
             </a:r>
           </a:p>
         </p:txBody>
@@ -22884,7 +22884,7 @@
         </p:nvSpPr>
         <p:spPr>
           <a:xfrm>
-            <a:off x="9372600" y="3928872"/>
+            <a:off x="9372600" y="4593336"/>
             <a:ext cx="614476" cy="201168"/>
           </a:xfrm>
           <a:prstGeom prst="roundRect">
@@ -22933,7 +22933,7 @@
         </p:nvSpPr>
         <p:spPr>
           <a:xfrm>
-            <a:off x="9372600" y="3928872"/>
+            <a:off x="9372600" y="4593336"/>
             <a:ext cx="614476" cy="201168"/>
           </a:xfrm>
           <a:prstGeom prst="rect">
@@ -22968,7 +22968,7 @@
         </p:nvSpPr>
         <p:spPr>
           <a:xfrm>
-            <a:off x="10060228" y="3928872"/>
+            <a:off x="10060228" y="4593336"/>
             <a:ext cx="784555" cy="201168"/>
           </a:xfrm>
           <a:prstGeom prst="roundRect">
@@ -23017,7 +23017,7 @@
         </p:nvSpPr>
         <p:spPr>
           <a:xfrm>
-            <a:off x="10060228" y="3928872"/>
+            <a:off x="10060228" y="4593336"/>
             <a:ext cx="784555" cy="201168"/>
           </a:xfrm>
           <a:prstGeom prst="rect">
@@ -23188,7 +23188,7 @@
                 </a:solidFill>
                 <a:latin typeface="Inter"/>
               </a:rPr>
-              <a:t>3,8 %</a:t>
+              <a:t>3,9 %</a:t>
             </a:r>
           </a:p>
         </p:txBody>
@@ -23290,7 +23290,7 @@
                 </a:solidFill>
                 <a:latin typeface="Inter"/>
               </a:rPr>
-              <a:t>2,8 %</a:t>
+              <a:t>2,9 %</a:t>
             </a:r>
           </a:p>
         </p:txBody>
@@ -23518,7 +23518,7 @@
         </p:nvSpPr>
         <p:spPr>
           <a:xfrm>
-            <a:off x="457200" y="4602480"/>
+            <a:off x="457200" y="4934712"/>
             <a:ext cx="201168" cy="182880"/>
           </a:xfrm>
           <a:prstGeom prst="rect">
@@ -23539,7 +23539,7 @@
                 </a:solidFill>
                 <a:latin typeface="Inter"/>
               </a:rPr>
-              <a:t>8</a:t>
+              <a:t>9</a:t>
             </a:r>
           </a:p>
         </p:txBody>
@@ -23552,7 +23552,7 @@
         </p:nvSpPr>
         <p:spPr>
           <a:xfrm>
-            <a:off x="731520" y="4584192"/>
+            <a:off x="731520" y="4916424"/>
             <a:ext cx="2011680" cy="329184"/>
           </a:xfrm>
           <a:prstGeom prst="rect">
@@ -23586,7 +23586,7 @@
         </p:nvSpPr>
         <p:spPr>
           <a:xfrm>
-            <a:off x="2788920" y="4584192"/>
+            <a:off x="2788920" y="4916424"/>
             <a:ext cx="548640" cy="201168"/>
           </a:xfrm>
           <a:prstGeom prst="rect">
@@ -23607,7 +23607,7 @@
                 </a:solidFill>
                 <a:latin typeface="Inter"/>
               </a:rPr>
-              <a:t>3,5 %</a:t>
+              <a:t>3,6 %</a:t>
             </a:r>
           </a:p>
         </p:txBody>
@@ -23620,7 +23620,7 @@
         </p:nvSpPr>
         <p:spPr>
           <a:xfrm>
-            <a:off x="3429000" y="4584192"/>
+            <a:off x="3429000" y="4916424"/>
             <a:ext cx="2834640" cy="329184"/>
           </a:xfrm>
           <a:prstGeom prst="rect">
@@ -23654,7 +23654,7 @@
         </p:nvSpPr>
         <p:spPr>
           <a:xfrm>
-            <a:off x="6355080" y="4584192"/>
+            <a:off x="6355080" y="4916424"/>
             <a:ext cx="1965960" cy="329184"/>
           </a:xfrm>
           <a:prstGeom prst="rect">
@@ -23688,7 +23688,7 @@
         </p:nvSpPr>
         <p:spPr>
           <a:xfrm>
-            <a:off x="8412480" y="4584192"/>
+            <a:off x="8412480" y="4916424"/>
             <a:ext cx="822960" cy="201168"/>
           </a:xfrm>
           <a:prstGeom prst="rect">
@@ -23709,7 +23709,7 @@
                 </a:solidFill>
                 <a:latin typeface="Inter"/>
               </a:rPr>
-              <a:t>3,2 %</a:t>
+              <a:t>3,1 %</a:t>
             </a:r>
           </a:p>
         </p:txBody>
@@ -23722,7 +23722,7 @@
         </p:nvSpPr>
         <p:spPr>
           <a:xfrm>
-            <a:off x="9372600" y="4593336"/>
+            <a:off x="9372600" y="4925568"/>
             <a:ext cx="501091" cy="201168"/>
           </a:xfrm>
           <a:prstGeom prst="roundRect">
@@ -23771,7 +23771,7 @@
         </p:nvSpPr>
         <p:spPr>
           <a:xfrm>
-            <a:off x="9372600" y="4593336"/>
+            <a:off x="9372600" y="4925568"/>
             <a:ext cx="501091" cy="201168"/>
           </a:xfrm>
           <a:prstGeom prst="rect">
@@ -23806,7 +23806,7 @@
         </p:nvSpPr>
         <p:spPr>
           <a:xfrm>
-            <a:off x="9946843" y="4593336"/>
+            <a:off x="9946843" y="4925568"/>
             <a:ext cx="614476" cy="201168"/>
           </a:xfrm>
           <a:prstGeom prst="roundRect">
@@ -23855,7 +23855,7 @@
         </p:nvSpPr>
         <p:spPr>
           <a:xfrm>
-            <a:off x="9946843" y="4593336"/>
+            <a:off x="9946843" y="4925568"/>
             <a:ext cx="614476" cy="201168"/>
           </a:xfrm>
           <a:prstGeom prst="rect">
@@ -23937,7 +23937,7 @@
         </p:nvSpPr>
         <p:spPr>
           <a:xfrm>
-            <a:off x="457200" y="4934712"/>
+            <a:off x="457200" y="5266944"/>
             <a:ext cx="201168" cy="182880"/>
           </a:xfrm>
           <a:prstGeom prst="rect">
@@ -23958,7 +23958,7 @@
                 </a:solidFill>
                 <a:latin typeface="Inter"/>
               </a:rPr>
-              <a:t>9</a:t>
+              <a:t>10</a:t>
             </a:r>
           </a:p>
         </p:txBody>
@@ -23971,7 +23971,7 @@
         </p:nvSpPr>
         <p:spPr>
           <a:xfrm>
-            <a:off x="731520" y="4916424"/>
+            <a:off x="731520" y="5248656"/>
             <a:ext cx="2011680" cy="329184"/>
           </a:xfrm>
           <a:prstGeom prst="rect">
@@ -24005,7 +24005,7 @@
         </p:nvSpPr>
         <p:spPr>
           <a:xfrm>
-            <a:off x="2788920" y="4916424"/>
+            <a:off x="2788920" y="5248656"/>
             <a:ext cx="548640" cy="201168"/>
           </a:xfrm>
           <a:prstGeom prst="rect">
@@ -24026,7 +24026,7 @@
                 </a:solidFill>
                 <a:latin typeface="Inter"/>
               </a:rPr>
-              <a:t>3,2 %</a:t>
+              <a:t>3,1 %</a:t>
             </a:r>
           </a:p>
         </p:txBody>
@@ -24039,7 +24039,7 @@
         </p:nvSpPr>
         <p:spPr>
           <a:xfrm>
-            <a:off x="3429000" y="4916424"/>
+            <a:off x="3429000" y="5248656"/>
             <a:ext cx="2834640" cy="329184"/>
           </a:xfrm>
           <a:prstGeom prst="rect">
@@ -24073,7 +24073,7 @@
         </p:nvSpPr>
         <p:spPr>
           <a:xfrm>
-            <a:off x="6355080" y="4916424"/>
+            <a:off x="6355080" y="5248656"/>
             <a:ext cx="1965960" cy="329184"/>
           </a:xfrm>
           <a:prstGeom prst="rect">
@@ -24107,7 +24107,7 @@
         </p:nvSpPr>
         <p:spPr>
           <a:xfrm>
-            <a:off x="8412480" y="4916424"/>
+            <a:off x="8412480" y="5248656"/>
             <a:ext cx="822960" cy="201168"/>
           </a:xfrm>
           <a:prstGeom prst="rect">
@@ -24141,7 +24141,7 @@
         </p:nvSpPr>
         <p:spPr>
           <a:xfrm>
-            <a:off x="9372600" y="4925568"/>
+            <a:off x="9372600" y="5257800"/>
             <a:ext cx="557784" cy="201168"/>
           </a:xfrm>
           <a:prstGeom prst="roundRect">
@@ -24190,7 +24190,7 @@
         </p:nvSpPr>
         <p:spPr>
           <a:xfrm>
-            <a:off x="9372600" y="4925568"/>
+            <a:off x="9372600" y="5257800"/>
             <a:ext cx="557784" cy="201168"/>
           </a:xfrm>
           <a:prstGeom prst="rect">
@@ -24225,7 +24225,7 @@
         </p:nvSpPr>
         <p:spPr>
           <a:xfrm>
-            <a:off x="10003536" y="4925568"/>
+            <a:off x="10003536" y="5257800"/>
             <a:ext cx="614476" cy="201168"/>
           </a:xfrm>
           <a:prstGeom prst="roundRect">
@@ -24274,7 +24274,7 @@
         </p:nvSpPr>
         <p:spPr>
           <a:xfrm>
-            <a:off x="10003536" y="4925568"/>
+            <a:off x="10003536" y="5257800"/>
             <a:ext cx="614476" cy="201168"/>
           </a:xfrm>
           <a:prstGeom prst="rect">
@@ -24356,7 +24356,7 @@
         </p:nvSpPr>
         <p:spPr>
           <a:xfrm>
-            <a:off x="457200" y="5266944"/>
+            <a:off x="457200" y="3938016"/>
             <a:ext cx="201168" cy="182880"/>
           </a:xfrm>
           <a:prstGeom prst="rect">
@@ -24377,7 +24377,7 @@
                 </a:solidFill>
                 <a:latin typeface="Inter"/>
               </a:rPr>
-              <a:t>10</a:t>
+              <a:t>6</a:t>
             </a:r>
           </a:p>
         </p:txBody>
@@ -24390,7 +24390,7 @@
         </p:nvSpPr>
         <p:spPr>
           <a:xfrm>
-            <a:off x="731520" y="5248656"/>
+            <a:off x="731520" y="3919728"/>
             <a:ext cx="2011680" cy="329184"/>
           </a:xfrm>
           <a:prstGeom prst="rect">
@@ -24411,7 +24411,7 @@
                 </a:solidFill>
                 <a:latin typeface="Inter"/>
               </a:rPr>
-              <a:t>Choisir une imprimante pour la maison</a:t>
+              <a:t>Choisir une friteuse sans huile</a:t>
             </a:r>
           </a:p>
         </p:txBody>
@@ -24424,7 +24424,7 @@
         </p:nvSpPr>
         <p:spPr>
           <a:xfrm>
-            <a:off x="2788920" y="5248656"/>
+            <a:off x="2788920" y="3919728"/>
             <a:ext cx="548640" cy="201168"/>
           </a:xfrm>
           <a:prstGeom prst="rect">
@@ -24445,7 +24445,7 @@
                 </a:solidFill>
                 <a:latin typeface="Inter"/>
               </a:rPr>
-              <a:t>2,9 %</a:t>
+              <a:t>4,1 %</a:t>
             </a:r>
           </a:p>
         </p:txBody>
@@ -24458,7 +24458,7 @@
         </p:nvSpPr>
         <p:spPr>
           <a:xfrm>
-            <a:off x="3429000" y="5248656"/>
+            <a:off x="3429000" y="3919728"/>
             <a:ext cx="2834640" cy="329184"/>
           </a:xfrm>
           <a:prstGeom prst="rect">
@@ -24479,7 +24479,7 @@
                 </a:solidFill>
                 <a:latin typeface="Inter"/>
               </a:rPr>
-              <a:t>« Quelle imprimante choisir pour imprimer peu mais régulièrement ? »</a:t>
+              <a:t>« Quel airfryer choisir pour cuisiner pour quatre personnes ? »</a:t>
             </a:r>
           </a:p>
         </p:txBody>
@@ -24492,7 +24492,7 @@
         </p:nvSpPr>
         <p:spPr>
           <a:xfrm>
-            <a:off x="6355080" y="5248656"/>
+            <a:off x="6355080" y="3919728"/>
             <a:ext cx="1965960" cy="329184"/>
           </a:xfrm>
           <a:prstGeom prst="rect">
@@ -24513,7 +24513,7 @@
                 </a:solidFill>
                 <a:latin typeface="Inter"/>
               </a:rPr>
-              <a:t>Brother HL-L1242W, Canon MAXIFY BX110</a:t>
+              <a:t>Ninja Foodi Dual Zone, Philips Airfryer XXL</a:t>
             </a:r>
           </a:p>
         </p:txBody>
@@ -24526,7 +24526,7 @@
         </p:nvSpPr>
         <p:spPr>
           <a:xfrm>
-            <a:off x="8412480" y="5248656"/>
+            <a:off x="8412480" y="3919728"/>
             <a:ext cx="822960" cy="201168"/>
           </a:xfrm>
           <a:prstGeom prst="rect">
@@ -24547,7 +24547,7 @@
                 </a:solidFill>
                 <a:latin typeface="Inter"/>
               </a:rPr>
-              <a:t>1,8 %</a:t>
+              <a:t>3,4 %</a:t>
             </a:r>
           </a:p>
         </p:txBody>
@@ -24560,7 +24560,7 @@
         </p:nvSpPr>
         <p:spPr>
           <a:xfrm>
-            <a:off x="9372600" y="5257800"/>
+            <a:off x="9372600" y="3928872"/>
             <a:ext cx="614476" cy="201168"/>
           </a:xfrm>
           <a:prstGeom prst="roundRect">
@@ -24609,7 +24609,7 @@
         </p:nvSpPr>
         <p:spPr>
           <a:xfrm>
-            <a:off x="9372600" y="5257800"/>
+            <a:off x="9372600" y="3928872"/>
             <a:ext cx="614476" cy="201168"/>
           </a:xfrm>
           <a:prstGeom prst="rect">
@@ -24644,8 +24644,8 @@
         </p:nvSpPr>
         <p:spPr>
           <a:xfrm>
-            <a:off x="10060228" y="5257800"/>
-            <a:ext cx="784555" cy="201168"/>
+            <a:off x="10060228" y="3928872"/>
+            <a:ext cx="557784" cy="201168"/>
           </a:xfrm>
           <a:prstGeom prst="roundRect">
             <a:avLst>
@@ -24693,8 +24693,8 @@
         </p:nvSpPr>
         <p:spPr>
           <a:xfrm>
-            <a:off x="10060228" y="5257800"/>
-            <a:ext cx="784555" cy="201168"/>
+            <a:off x="10060228" y="3928872"/>
+            <a:ext cx="557784" cy="201168"/>
           </a:xfrm>
           <a:prstGeom prst="rect">
             <a:avLst/>
@@ -24715,7 +24715,7 @@
                 </a:solidFill>
                 <a:latin typeface="Inter"/>
               </a:rPr>
-              <a:t>Cdiscount</a:t>
+              <a:t>Darty</a:t>
             </a:r>
           </a:p>
         </p:txBody>
@@ -24749,7 +24749,7 @@
                 </a:solidFill>
                 <a:latin typeface="Inter"/>
               </a:rPr>
-              <a:t>Autres intentions : 57,2 %</a:t>
+              <a:t>Autres intentions : 56,0 %</a:t>
             </a:r>
           </a:p>
         </p:txBody>
@@ -24829,7 +24829,7 @@
             </a:r>
             <a:r>
               <a:rPr lang="fr-FR" sz="900"/>
-              <a:t>Les intentions d’achat évoluent peu, tandis que Boulanger gagne légèrement en visibilité sur la majorité des catégories.</a:t>
+              <a:t>Le classement bouge peu, mais la friteuse sans huile fait son entrée dans le top 10 et Boulanger gagne légèrement en visibilité sur la majorité des catégories.</a:t>
             </a:r>
           </a:p>
           <a:p>
@@ -24847,7 +24847,7 @@
           <a:p>
             <a:r>
               <a:rPr lang="fr-FR" sz="900"/>
-              <a:t>Imprimantes et batteries externes : une visibilité faible et stable. La présence de Boulanger reste à respectivement 1,8 % et 2,0 %, les deux niveaux les plus bas du top 10.</a:t>
+              <a:t>Friteuses sans huile : nouvelle entrée (4,1 % des conversations), avec une présence Boulanger déjà à 3,4 %. Batteries externes : la plus faible visibilité du top 10 (2,1 %).</a:t>
             </a:r>
           </a:p>
         </p:txBody>
@@ -26773,7 +26773,7 @@
                 </a:solidFill>
                 <a:latin typeface="Inter"/>
               </a:rPr>
-              <a:t>16 %</a:t>
+              <a:t>20 %</a:t>
             </a:r>
           </a:p>
         </p:txBody>
@@ -26807,7 +26807,7 @@
                 </a:solidFill>
                 <a:latin typeface="Inter"/>
               </a:rPr>
-              <a:t>Face à Back Market</a:t>
+              <a:t>Face à E.Leclerc</a:t>
             </a:r>
           </a:p>
         </p:txBody>
@@ -27123,7 +27123,7 @@
                 </a:solidFill>
                 <a:latin typeface="Inter"/>
               </a:rPr>
-              <a:t> : Back Market concentre 16 % des comparaisons, soit deux fois Amazon.</a:t>
+              <a:t> : E.Leclerc et Amazon concentrent 39 % des comparaisons.</a:t>
             </a:r>
           </a:p>
         </p:txBody>

</xml_diff>

<commit_message>
Ajout slide répartition des médias
Co-Authored-By: Claude Opus 5.5 <noreply@anthropic.com>
Claude-Session: https://claude.ai/code/session_014FKzAw3xP1tDY13CjjrvxH
</commit_message>
<xml_diff>
--- a/20261001_Rapport_Boulanger_Hebdo.pptx
+++ b/20261001_Rapport_Boulanger_Hebdo.pptx
@@ -15,6 +15,7 @@
     <p:sldId id="260" r:id="rId10"/>
     <p:sldId id="261" r:id="rId11"/>
     <p:sldId id="262" r:id="rId12"/>
+    <p:sldId id="290" r:id="rId900"/>
     <p:sldId id="263" r:id="rId13"/>
     <p:sldId id="264" r:id="rId14"/>
     <p:sldId id="265" r:id="rId15"/>
@@ -7298,6 +7299,2679 @@
               <a:rPr sz="700" b="1" i="0" spc="110">
                 <a:solidFill>
                   <a:srgbClr val="F26B2A"/>
+                </a:solidFill>
+                <a:latin typeface="Inter"/>
+              </a:rPr>
+              <a:t>03 PISTES DE RECO</a:t>
+            </a:r>
+          </a:p>
+        </p:txBody>
+      </p:sp>
+    </p:spTree>
+  </p:cSld>
+  <p:clrMapOvr>
+    <a:masterClrMapping/>
+  </p:clrMapOvr>
+</p:sld>
+</file>
+
+<file path=ppt/slides/slide12.xml><?xml version="1.0" encoding="utf-8"?>
+<p:sld xmlns:a="http://schemas.openxmlformats.org/drawingml/2006/main" xmlns:r="http://schemas.openxmlformats.org/officeDocument/2006/relationships" xmlns:p="http://schemas.openxmlformats.org/presentationml/2006/main">
+  <p:cSld>
+    <p:spTree>
+      <p:nvGrpSpPr>
+        <p:cNvPr id="1" name=""/>
+        <p:cNvGrpSpPr/>
+        <p:nvPr/>
+      </p:nvGrpSpPr>
+      <p:grpSpPr>
+        <a:xfrm>
+          <a:off x="0" y="0"/>
+          <a:ext cx="0" cy="0"/>
+          <a:chOff x="0" y="0"/>
+          <a:chExt cx="0" cy="0"/>
+        </a:xfrm>
+      </p:grpSpPr>
+      <p:sp>
+        <p:nvSpPr>
+          <p:cNvPr id="101" name="TextBox 1"/>
+          <p:cNvSpPr txBox="1"/>
+          <p:nvPr/>
+        </p:nvSpPr>
+        <p:spPr>
+          <a:xfrm>
+            <a:off x="457200" y="384048"/>
+            <a:ext cx="8229600" cy="182880"/>
+          </a:xfrm>
+          <a:prstGeom prst="rect">
+            <a:avLst/>
+          </a:prstGeom>
+          <a:noFill/>
+        </p:spPr>
+        <p:txBody>
+          <a:bodyPr wrap="square" lIns="0" tIns="0" rIns="0" bIns="0">
+            <a:spAutoFit/>
+          </a:bodyPr>
+          <a:lstStyle/>
+          <a:p>
+            <a:r>
+              <a:rPr sz="850" b="1" i="0" spc="200">
+                <a:solidFill>
+                  <a:srgbClr val="6B6B6B"/>
+                </a:solidFill>
+                <a:latin typeface="Inter"/>
+              </a:rPr>
+              <a:t>RÉPARTITION DES MÉDIAS · PÉRIODE ANALYSÉE 24/09/2026 → 30/09/2026</a:t>
+            </a:r>
+          </a:p>
+        </p:txBody>
+      </p:sp>
+      <p:sp>
+        <p:nvSpPr>
+          <p:cNvPr id="102" name="TextBox 2"/>
+          <p:cNvSpPr txBox="1"/>
+          <p:nvPr/>
+        </p:nvSpPr>
+        <p:spPr>
+          <a:xfrm>
+            <a:off x="457200" y="603504"/>
+            <a:ext cx="7315200" cy="548640"/>
+          </a:xfrm>
+          <a:prstGeom prst="rect">
+            <a:avLst/>
+          </a:prstGeom>
+          <a:noFill/>
+        </p:spPr>
+        <p:txBody>
+          <a:bodyPr wrap="square" lIns="0" tIns="0" rIns="0" bIns="0">
+            <a:spAutoFit/>
+          </a:bodyPr>
+          <a:lstStyle/>
+          <a:p>
+            <a:r>
+              <a:rPr sz="2600" b="1" i="0">
+                <a:solidFill>
+                  <a:srgbClr val="0A0A0A"/>
+                </a:solidFill>
+                <a:latin typeface="Inter"/>
+              </a:rPr>
+              <a:t>Boulanger</a:t>
+            </a:r>
+          </a:p>
+        </p:txBody>
+      </p:sp>
+      <p:sp>
+        <p:nvSpPr>
+          <p:cNvPr id="103" name="TextBox 3"/>
+          <p:cNvSpPr txBox="1"/>
+          <p:nvPr/>
+        </p:nvSpPr>
+        <p:spPr>
+          <a:xfrm>
+            <a:off x="8531352" y="548640"/>
+            <a:ext cx="3200400" cy="182880"/>
+          </a:xfrm>
+          <a:prstGeom prst="rect">
+            <a:avLst/>
+          </a:prstGeom>
+          <a:noFill/>
+        </p:spPr>
+        <p:txBody>
+          <a:bodyPr wrap="square" lIns="0" tIns="0" rIns="0" bIns="0">
+            <a:spAutoFit/>
+          </a:bodyPr>
+          <a:lstStyle/>
+          <a:p>
+            <a:pPr algn="r"/>
+            <a:r>
+              <a:rPr sz="750" b="1" i="0" spc="200">
+                <a:solidFill>
+                  <a:srgbClr val="98A2B3"/>
+                </a:solidFill>
+                <a:latin typeface="Inter"/>
+              </a:rPr>
+              <a:t>PÉRIODE</a:t>
+            </a:r>
+          </a:p>
+        </p:txBody>
+      </p:sp>
+      <p:sp>
+        <p:nvSpPr>
+          <p:cNvPr id="104" name="TextBox 4"/>
+          <p:cNvSpPr txBox="1"/>
+          <p:nvPr/>
+        </p:nvSpPr>
+        <p:spPr>
+          <a:xfrm>
+            <a:off x="8531352" y="749808"/>
+            <a:ext cx="3200400" cy="228600"/>
+          </a:xfrm>
+          <a:prstGeom prst="rect">
+            <a:avLst/>
+          </a:prstGeom>
+          <a:noFill/>
+        </p:spPr>
+        <p:txBody>
+          <a:bodyPr wrap="square" lIns="0" tIns="0" rIns="0" bIns="0">
+            <a:spAutoFit/>
+          </a:bodyPr>
+          <a:lstStyle/>
+          <a:p>
+            <a:pPr algn="r"/>
+            <a:r>
+              <a:rPr sz="1100" b="0" i="0">
+                <a:solidFill>
+                  <a:srgbClr val="6B6B6B"/>
+                </a:solidFill>
+                <a:latin typeface="Inter"/>
+              </a:rPr>
+              <a:t>24/09/2026 → 30/09/2026</a:t>
+            </a:r>
+          </a:p>
+        </p:txBody>
+      </p:sp>
+      <p:sp>
+        <p:nvSpPr>
+          <p:cNvPr id="105" name="Rounded Rectangle 5"/>
+          <p:cNvSpPr/>
+          <p:nvPr/>
+        </p:nvSpPr>
+        <p:spPr>
+          <a:xfrm>
+            <a:off x="9720072" y="109728"/>
+            <a:ext cx="2011680" cy="292608"/>
+          </a:xfrm>
+          <a:prstGeom prst="roundRect">
+            <a:avLst>
+              <a:gd name="adj" fmla="val 50000"/>
+            </a:avLst>
+          </a:prstGeom>
+          <a:solidFill>
+            <a:srgbClr val="F26B2A"/>
+          </a:solidFill>
+          <a:ln w="12700">
+            <a:solidFill>
+              <a:srgbClr val="F26B2A"/>
+            </a:solidFill>
+          </a:ln>
+          <a:effectLst/>
+        </p:spPr>
+        <p:style>
+          <a:lnRef idx="1">
+            <a:schemeClr val="accent1"/>
+          </a:lnRef>
+          <a:fillRef idx="3">
+            <a:schemeClr val="accent1"/>
+          </a:fillRef>
+          <a:effectRef idx="2">
+            <a:schemeClr val="accent1"/>
+          </a:effectRef>
+          <a:fontRef idx="minor">
+            <a:schemeClr val="lt1"/>
+          </a:fontRef>
+        </p:style>
+        <p:txBody>
+          <a:bodyPr wrap="square" rtlCol="0" anchor="ctr"/>
+          <a:lstStyle/>
+          <a:p>
+            <a:pPr algn="ctr"/>
+            <a:endParaRPr/>
+          </a:p>
+        </p:txBody>
+      </p:sp>
+      <p:sp>
+        <p:nvSpPr>
+          <p:cNvPr id="106" name="TextBox 6"/>
+          <p:cNvSpPr txBox="1"/>
+          <p:nvPr/>
+        </p:nvSpPr>
+        <p:spPr>
+          <a:xfrm>
+            <a:off x="9720072" y="109728"/>
+            <a:ext cx="2011680" cy="292608"/>
+          </a:xfrm>
+          <a:prstGeom prst="rect">
+            <a:avLst/>
+          </a:prstGeom>
+          <a:noFill/>
+        </p:spPr>
+        <p:txBody>
+          <a:bodyPr wrap="square" lIns="0" tIns="0" rIns="0" bIns="0" anchor="ctr">
+            <a:spAutoFit/>
+          </a:bodyPr>
+          <a:lstStyle/>
+          <a:p>
+            <a:pPr algn="ctr"/>
+            <a:r>
+              <a:rPr sz="750" b="1" i="0" spc="100">
+                <a:solidFill>
+                  <a:srgbClr val="FFFFFF"/>
+                </a:solidFill>
+                <a:latin typeface="Inter"/>
+              </a:rPr>
+              <a:t>VALEURS PROJETÉES</a:t>
+            </a:r>
+          </a:p>
+        </p:txBody>
+      </p:sp>
+      <p:sp>
+        <p:nvSpPr>
+          <p:cNvPr id="107" name="Rectangle 7"/>
+          <p:cNvSpPr/>
+          <p:nvPr/>
+        </p:nvSpPr>
+        <p:spPr>
+          <a:xfrm>
+            <a:off x="457200" y="1188720"/>
+            <a:ext cx="11274552" cy="9144"/>
+          </a:xfrm>
+          <a:prstGeom prst="rect">
+            <a:avLst/>
+          </a:prstGeom>
+          <a:solidFill>
+            <a:srgbClr val="ECEBE7"/>
+          </a:solidFill>
+          <a:ln w="12700">
+            <a:solidFill>
+              <a:srgbClr val="ECEBE7"/>
+            </a:solidFill>
+          </a:ln>
+          <a:effectLst/>
+        </p:spPr>
+        <p:style>
+          <a:lnRef idx="1">
+            <a:schemeClr val="accent1"/>
+          </a:lnRef>
+          <a:fillRef idx="3">
+            <a:schemeClr val="accent1"/>
+          </a:fillRef>
+          <a:effectRef idx="2">
+            <a:schemeClr val="accent1"/>
+          </a:effectRef>
+          <a:fontRef idx="minor">
+            <a:schemeClr val="lt1"/>
+          </a:fontRef>
+        </p:style>
+        <p:txBody>
+          <a:bodyPr wrap="square" rtlCol="0" anchor="ctr"/>
+          <a:lstStyle/>
+          <a:p>
+            <a:pPr algn="ctr"/>
+            <a:endParaRPr/>
+          </a:p>
+        </p:txBody>
+      </p:sp>
+      <p:sp>
+        <p:nvSpPr>
+          <p:cNvPr id="108" name="TextBox 8"/>
+          <p:cNvSpPr txBox="1"/>
+          <p:nvPr/>
+        </p:nvSpPr>
+        <p:spPr>
+          <a:xfrm>
+            <a:off x="457200" y="1298448"/>
+            <a:ext cx="6400800" cy="256032"/>
+          </a:xfrm>
+          <a:prstGeom prst="rect">
+            <a:avLst/>
+          </a:prstGeom>
+          <a:noFill/>
+        </p:spPr>
+        <p:txBody>
+          <a:bodyPr wrap="square" lIns="0" tIns="0" rIns="0" bIns="0">
+            <a:spAutoFit/>
+          </a:bodyPr>
+          <a:lstStyle/>
+          <a:p>
+            <a:r>
+              <a:rPr sz="1400" b="1" i="0">
+                <a:solidFill>
+                  <a:srgbClr val="0A0A0A"/>
+                </a:solidFill>
+                <a:latin typeface="Inter"/>
+              </a:rPr>
+              <a:t>Répartition de la diffusion par média</a:t>
+            </a:r>
+          </a:p>
+        </p:txBody>
+      </p:sp>
+      <p:sp>
+        <p:nvSpPr>
+          <p:cNvPr id="109" name="TextBox 9"/>
+          <p:cNvSpPr txBox="1"/>
+          <p:nvPr/>
+        </p:nvSpPr>
+        <p:spPr>
+          <a:xfrm>
+            <a:off x="457200" y="1572768"/>
+            <a:ext cx="10972800" cy="201168"/>
+          </a:xfrm>
+          <a:prstGeom prst="rect">
+            <a:avLst/>
+          </a:prstGeom>
+          <a:noFill/>
+        </p:spPr>
+        <p:txBody>
+          <a:bodyPr wrap="square" lIns="0" tIns="0" rIns="0" bIns="0">
+            <a:spAutoFit/>
+          </a:bodyPr>
+          <a:lstStyle/>
+          <a:p>
+            <a:r>
+              <a:rPr sz="850" b="0" i="0">
+                <a:solidFill>
+                  <a:srgbClr val="6B6B6B"/>
+                </a:solidFill>
+                <a:latin typeface="Inter"/>
+              </a:rPr>
+              <a:t>Part des impressions de la campagne par site éditeur · évolution sur les deux derniers jours.</a:t>
+            </a:r>
+          </a:p>
+        </p:txBody>
+      </p:sp>
+      <p:sp>
+        <p:nvSpPr>
+          <p:cNvPr id="110" name="TextBox 131"/>
+          <p:cNvSpPr txBox="1"/>
+          <p:nvPr/>
+        </p:nvSpPr>
+        <p:spPr>
+          <a:xfrm>
+            <a:off x="457200" y="118872"/>
+            <a:ext cx="9144000" cy="201168"/>
+          </a:xfrm>
+          <a:prstGeom prst="rect">
+            <a:avLst/>
+          </a:prstGeom>
+          <a:noFill/>
+        </p:spPr>
+        <p:txBody>
+          <a:bodyPr wrap="square" lIns="0" tIns="0" rIns="0" bIns="0">
+            <a:spAutoFit/>
+          </a:bodyPr>
+          <a:lstStyle/>
+          <a:p>
+            <a:r>
+              <a:rPr sz="700" b="0" i="0" spc="110">
+                <a:solidFill>
+                  <a:srgbClr val="A8A49C"/>
+                </a:solidFill>
+                <a:latin typeface="Inter"/>
+              </a:rPr>
+              <a:t>01 INDICATEURS</a:t>
+            </a:r>
+            <a:r>
+              <a:rPr sz="700" b="0" i="0" spc="110">
+                <a:solidFill>
+                  <a:srgbClr val="C9C6C0"/>
+                </a:solidFill>
+                <a:latin typeface="Inter"/>
+              </a:rPr>
+              <a:t>   ·   </a:t>
+            </a:r>
+            <a:r>
+              <a:rPr sz="700" b="1" i="0" spc="110">
+                <a:solidFill>
+                  <a:srgbClr val="F26B2A"/>
+                </a:solidFill>
+                <a:latin typeface="Inter"/>
+              </a:rPr>
+              <a:t>02 BOULANGER</a:t>
+            </a:r>
+            <a:r>
+              <a:rPr sz="700" b="0" i="0" spc="110">
+                <a:solidFill>
+                  <a:srgbClr val="C9C6C0"/>
+                </a:solidFill>
+                <a:latin typeface="Inter"/>
+              </a:rPr>
+              <a:t>   ·   </a:t>
+            </a:r>
+            <a:r>
+              <a:rPr sz="700" b="0" i="0" spc="110">
+                <a:solidFill>
+                  <a:srgbClr val="A8A49C"/>
+                </a:solidFill>
+                <a:latin typeface="Inter"/>
+              </a:rPr>
+              <a:t>03 PISTES DE RECO</a:t>
+            </a:r>
+          </a:p>
+        </p:txBody>
+      </p:sp>
+      <p:sp>
+        <p:nvSpPr>
+          <p:cNvPr id="111" name="TextBox 11"/>
+          <p:cNvSpPr txBox="1"/>
+          <p:nvPr/>
+        </p:nvSpPr>
+        <p:spPr>
+          <a:xfrm>
+            <a:off x="731520" y="1901952"/>
+            <a:ext cx="2286000" cy="274320"/>
+          </a:xfrm>
+          <a:prstGeom prst="rect">
+            <a:avLst/>
+          </a:prstGeom>
+          <a:noFill/>
+        </p:spPr>
+        <p:txBody>
+          <a:bodyPr wrap="square" lIns="0" tIns="0" rIns="0" bIns="0">
+            <a:spAutoFit/>
+          </a:bodyPr>
+          <a:lstStyle/>
+          <a:p>
+            <a:r>
+              <a:rPr sz="700" b="1" i="0" spc="150">
+                <a:solidFill>
+                  <a:srgbClr val="98A2B3"/>
+                </a:solidFill>
+                <a:latin typeface="Inter"/>
+              </a:rPr>
+              <a:t>MÉDIA</a:t>
+            </a:r>
+          </a:p>
+        </p:txBody>
+      </p:sp>
+      <p:sp>
+        <p:nvSpPr>
+          <p:cNvPr id="112" name="TextBox 11"/>
+          <p:cNvSpPr txBox="1"/>
+          <p:nvPr/>
+        </p:nvSpPr>
+        <p:spPr>
+          <a:xfrm>
+            <a:off x="3337560" y="1901952"/>
+            <a:ext cx="4572000" cy="274320"/>
+          </a:xfrm>
+          <a:prstGeom prst="rect">
+            <a:avLst/>
+          </a:prstGeom>
+          <a:noFill/>
+        </p:spPr>
+        <p:txBody>
+          <a:bodyPr wrap="square" lIns="0" tIns="0" rIns="0" bIns="0">
+            <a:spAutoFit/>
+          </a:bodyPr>
+          <a:lstStyle/>
+          <a:p>
+            <a:r>
+              <a:rPr sz="700" b="1" i="0" spc="150">
+                <a:solidFill>
+                  <a:srgbClr val="98A2B3"/>
+                </a:solidFill>
+                <a:latin typeface="Inter"/>
+              </a:rPr>
+              <a:t>PART DES IMPRESSIONS</a:t>
+            </a:r>
+          </a:p>
+        </p:txBody>
+      </p:sp>
+      <p:sp>
+        <p:nvSpPr>
+          <p:cNvPr id="113" name="TextBox 11"/>
+          <p:cNvSpPr txBox="1"/>
+          <p:nvPr/>
+        </p:nvSpPr>
+        <p:spPr>
+          <a:xfrm>
+            <a:off x="8412480" y="1901952"/>
+            <a:ext cx="914400" cy="274320"/>
+          </a:xfrm>
+          <a:prstGeom prst="rect">
+            <a:avLst/>
+          </a:prstGeom>
+          <a:noFill/>
+        </p:spPr>
+        <p:txBody>
+          <a:bodyPr wrap="square" lIns="0" tIns="0" rIns="0" bIns="0">
+            <a:spAutoFit/>
+          </a:bodyPr>
+          <a:lstStyle/>
+          <a:p>
+            <a:r>
+              <a:rPr sz="700" b="1" i="0" spc="150">
+                <a:solidFill>
+                  <a:srgbClr val="98A2B3"/>
+                </a:solidFill>
+                <a:latin typeface="Inter"/>
+              </a:rPr>
+              <a:t>PART</a:t>
+            </a:r>
+          </a:p>
+        </p:txBody>
+      </p:sp>
+      <p:sp>
+        <p:nvSpPr>
+          <p:cNvPr id="114" name="TextBox 11"/>
+          <p:cNvSpPr txBox="1"/>
+          <p:nvPr/>
+        </p:nvSpPr>
+        <p:spPr>
+          <a:xfrm>
+            <a:off x="9601200" y="1901952"/>
+            <a:ext cx="1600000" cy="274320"/>
+          </a:xfrm>
+          <a:prstGeom prst="rect">
+            <a:avLst/>
+          </a:prstGeom>
+          <a:noFill/>
+        </p:spPr>
+        <p:txBody>
+          <a:bodyPr wrap="square" lIns="0" tIns="0" rIns="0" bIns="0">
+            <a:spAutoFit/>
+          </a:bodyPr>
+          <a:lstStyle/>
+          <a:p>
+            <a:r>
+              <a:rPr sz="700" b="1" i="0" spc="150">
+                <a:solidFill>
+                  <a:srgbClr val="98A2B3"/>
+                </a:solidFill>
+                <a:latin typeface="Inter"/>
+              </a:rPr>
+              <a:t>ÉVOLUTION</a:t>
+            </a:r>
+          </a:p>
+        </p:txBody>
+      </p:sp>
+      <p:sp>
+        <p:nvSpPr>
+          <p:cNvPr id="115" name="Rectangle 16"/>
+          <p:cNvSpPr/>
+          <p:nvPr/>
+        </p:nvSpPr>
+        <p:spPr>
+          <a:xfrm>
+            <a:off x="457200" y="2194560"/>
+            <a:ext cx="11274552" cy="9144"/>
+          </a:xfrm>
+          <a:prstGeom prst="rect">
+            <a:avLst/>
+          </a:prstGeom>
+          <a:solidFill>
+            <a:srgbClr val="ECEBE7"/>
+          </a:solidFill>
+          <a:ln w="12700">
+            <a:solidFill>
+              <a:srgbClr val="ECEBE7"/>
+            </a:solidFill>
+          </a:ln>
+          <a:effectLst/>
+        </p:spPr>
+        <p:style>
+          <a:lnRef idx="1">
+            <a:schemeClr val="accent1"/>
+          </a:lnRef>
+          <a:fillRef idx="3">
+            <a:schemeClr val="accent1"/>
+          </a:fillRef>
+          <a:effectRef idx="2">
+            <a:schemeClr val="accent1"/>
+          </a:effectRef>
+          <a:fontRef idx="minor">
+            <a:schemeClr val="lt1"/>
+          </a:fontRef>
+        </p:style>
+        <p:txBody>
+          <a:bodyPr wrap="square" rtlCol="0" anchor="ctr"/>
+          <a:lstStyle/>
+          <a:p>
+            <a:pPr algn="ctr"/>
+            <a:endParaRPr/>
+          </a:p>
+        </p:txBody>
+      </p:sp>
+      <p:sp>
+        <p:nvSpPr>
+          <p:cNvPr id="116" name="TextBox 17"/>
+          <p:cNvSpPr txBox="1"/>
+          <p:nvPr/>
+        </p:nvSpPr>
+        <p:spPr>
+          <a:xfrm>
+            <a:off x="457200" y="2332848"/>
+            <a:ext cx="201168" cy="182880"/>
+          </a:xfrm>
+          <a:prstGeom prst="rect">
+            <a:avLst/>
+          </a:prstGeom>
+          <a:noFill/>
+        </p:spPr>
+        <p:txBody>
+          <a:bodyPr wrap="square" lIns="0" tIns="0" rIns="0" bIns="0">
+            <a:spAutoFit/>
+          </a:bodyPr>
+          <a:lstStyle/>
+          <a:p>
+            <a:r>
+              <a:rPr sz="800" b="0" i="0">
+                <a:solidFill>
+                  <a:srgbClr val="98A2B3"/>
+                </a:solidFill>
+                <a:latin typeface="Inter"/>
+              </a:rPr>
+              <a:t>1</a:t>
+            </a:r>
+          </a:p>
+        </p:txBody>
+      </p:sp>
+      <p:sp>
+        <p:nvSpPr>
+          <p:cNvPr id="117" name="TextBox 18"/>
+          <p:cNvSpPr txBox="1"/>
+          <p:nvPr/>
+        </p:nvSpPr>
+        <p:spPr>
+          <a:xfrm>
+            <a:off x="731520" y="2314560"/>
+            <a:ext cx="2400000" cy="329184"/>
+          </a:xfrm>
+          <a:prstGeom prst="rect">
+            <a:avLst/>
+          </a:prstGeom>
+          <a:noFill/>
+        </p:spPr>
+        <p:txBody>
+          <a:bodyPr wrap="square" lIns="0" tIns="0" rIns="0" bIns="0">
+            <a:spAutoFit/>
+          </a:bodyPr>
+          <a:lstStyle/>
+          <a:p>
+            <a:r>
+              <a:rPr sz="900" b="1" i="0">
+                <a:solidFill>
+                  <a:srgbClr val="0A0A0A"/>
+                </a:solidFill>
+                <a:latin typeface="Inter"/>
+              </a:rPr>
+              <a:t>Modes &amp; Travaux</a:t>
+            </a:r>
+          </a:p>
+        </p:txBody>
+      </p:sp>
+      <p:sp>
+        <p:nvSpPr>
+          <p:cNvPr id="118" name="Rounded Rectangle 24"/>
+          <p:cNvSpPr/>
+          <p:nvPr/>
+        </p:nvSpPr>
+        <p:spPr>
+          <a:xfrm>
+            <a:off x="3337560" y="2384560"/>
+            <a:ext cx="4572000" cy="64008"/>
+          </a:xfrm>
+          <a:prstGeom prst="roundRect">
+            <a:avLst>
+              <a:gd name="adj" fmla="val 50000"/>
+            </a:avLst>
+          </a:prstGeom>
+          <a:solidFill>
+            <a:srgbClr val="EDEBE7"/>
+          </a:solidFill>
+          <a:ln w="12700">
+            <a:solidFill>
+              <a:srgbClr val="EDEBE7"/>
+            </a:solidFill>
+          </a:ln>
+          <a:effectLst/>
+        </p:spPr>
+        <p:style>
+          <a:lnRef idx="1">
+            <a:schemeClr val="accent1"/>
+          </a:lnRef>
+          <a:fillRef idx="3">
+            <a:schemeClr val="accent1"/>
+          </a:fillRef>
+          <a:effectRef idx="2">
+            <a:schemeClr val="accent1"/>
+          </a:effectRef>
+          <a:fontRef idx="minor">
+            <a:schemeClr val="lt1"/>
+          </a:fontRef>
+        </p:style>
+        <p:txBody>
+          <a:bodyPr wrap="square" rtlCol="0" anchor="ctr"/>
+          <a:lstStyle/>
+          <a:p>
+            <a:pPr algn="ctr"/>
+            <a:endParaRPr/>
+          </a:p>
+        </p:txBody>
+      </p:sp>
+      <p:sp>
+        <p:nvSpPr>
+          <p:cNvPr id="119" name="Rounded Rectangle 25"/>
+          <p:cNvSpPr/>
+          <p:nvPr/>
+        </p:nvSpPr>
+        <p:spPr>
+          <a:xfrm>
+            <a:off x="3337560" y="2384560"/>
+            <a:ext cx="4572000" cy="64008"/>
+          </a:xfrm>
+          <a:prstGeom prst="roundRect">
+            <a:avLst>
+              <a:gd name="adj" fmla="val 50000"/>
+            </a:avLst>
+          </a:prstGeom>
+          <a:solidFill>
+            <a:srgbClr val="F26B2A"/>
+          </a:solidFill>
+          <a:ln w="12700">
+            <a:solidFill>
+              <a:srgbClr val="F26B2A"/>
+            </a:solidFill>
+          </a:ln>
+          <a:effectLst/>
+        </p:spPr>
+        <p:style>
+          <a:lnRef idx="1">
+            <a:schemeClr val="accent1"/>
+          </a:lnRef>
+          <a:fillRef idx="3">
+            <a:schemeClr val="accent1"/>
+          </a:fillRef>
+          <a:effectRef idx="2">
+            <a:schemeClr val="accent1"/>
+          </a:effectRef>
+          <a:fontRef idx="minor">
+            <a:schemeClr val="lt1"/>
+          </a:fontRef>
+        </p:style>
+        <p:txBody>
+          <a:bodyPr wrap="square" rtlCol="0" anchor="ctr"/>
+          <a:lstStyle/>
+          <a:p>
+            <a:pPr algn="ctr"/>
+            <a:endParaRPr/>
+          </a:p>
+        </p:txBody>
+      </p:sp>
+      <p:sp>
+        <p:nvSpPr>
+          <p:cNvPr id="120" name="TextBox 19"/>
+          <p:cNvSpPr txBox="1"/>
+          <p:nvPr/>
+        </p:nvSpPr>
+        <p:spPr>
+          <a:xfrm>
+            <a:off x="8412480" y="2314560"/>
+            <a:ext cx="914400" cy="201168"/>
+          </a:xfrm>
+          <a:prstGeom prst="rect">
+            <a:avLst/>
+          </a:prstGeom>
+          <a:noFill/>
+        </p:spPr>
+        <p:txBody>
+          <a:bodyPr wrap="square" lIns="0" tIns="0" rIns="0" bIns="0">
+            <a:spAutoFit/>
+          </a:bodyPr>
+          <a:lstStyle/>
+          <a:p>
+            <a:r>
+              <a:rPr sz="900" b="1" i="0">
+                <a:solidFill>
+                  <a:srgbClr val="0A0A0A"/>
+                </a:solidFill>
+                <a:latin typeface="Inter"/>
+              </a:rPr>
+              <a:t>31,6 %</a:t>
+            </a:r>
+          </a:p>
+        </p:txBody>
+      </p:sp>
+      <p:sp>
+        <p:nvSpPr>
+          <p:cNvPr id="121" name="TextBox 22"/>
+          <p:cNvSpPr txBox="1"/>
+          <p:nvPr/>
+        </p:nvSpPr>
+        <p:spPr>
+          <a:xfrm>
+            <a:off x="9601200" y="2314560"/>
+            <a:ext cx="1600000" cy="201168"/>
+          </a:xfrm>
+          <a:prstGeom prst="rect">
+            <a:avLst/>
+          </a:prstGeom>
+          <a:noFill/>
+        </p:spPr>
+        <p:txBody>
+          <a:bodyPr wrap="square" lIns="0" tIns="0" rIns="0" bIns="0">
+            <a:spAutoFit/>
+          </a:bodyPr>
+          <a:lstStyle/>
+          <a:p>
+            <a:r>
+              <a:rPr sz="900" b="1" i="0">
+                <a:solidFill>
+                  <a:srgbClr val="196B24"/>
+                </a:solidFill>
+                <a:latin typeface="Inter"/>
+              </a:rPr>
+              <a:t>▲ +0,3 pt</a:t>
+            </a:r>
+          </a:p>
+        </p:txBody>
+      </p:sp>
+      <p:sp>
+        <p:nvSpPr>
+          <p:cNvPr id="122" name="TextBox 19"/>
+          <p:cNvSpPr txBox="1"/>
+          <p:nvPr/>
+        </p:nvSpPr>
+        <p:spPr>
+          <a:xfrm>
+            <a:off x="10500000" y="2314560"/>
+            <a:ext cx="1100000" cy="201168"/>
+          </a:xfrm>
+          <a:prstGeom prst="rect">
+            <a:avLst/>
+          </a:prstGeom>
+          <a:noFill/>
+        </p:spPr>
+        <p:txBody>
+          <a:bodyPr wrap="square" lIns="0" tIns="0" rIns="0" bIns="0">
+            <a:spAutoFit/>
+          </a:bodyPr>
+          <a:lstStyle/>
+          <a:p>
+            <a:r>
+              <a:rPr sz="900" b="0" i="0">
+                <a:solidFill>
+                  <a:srgbClr val="98A2B3"/>
+                </a:solidFill>
+                <a:latin typeface="Inter"/>
+              </a:rPr>
+              <a:t>vs 31,3 %</a:t>
+            </a:r>
+          </a:p>
+        </p:txBody>
+      </p:sp>
+      <p:sp>
+        <p:nvSpPr>
+          <p:cNvPr id="123" name="Rectangle 16"/>
+          <p:cNvSpPr/>
+          <p:nvPr/>
+        </p:nvSpPr>
+        <p:spPr>
+          <a:xfrm>
+            <a:off x="457200" y="2674560"/>
+            <a:ext cx="11274552" cy="9144"/>
+          </a:xfrm>
+          <a:prstGeom prst="rect">
+            <a:avLst/>
+          </a:prstGeom>
+          <a:solidFill>
+            <a:srgbClr val="ECEBE7"/>
+          </a:solidFill>
+          <a:ln w="12700">
+            <a:solidFill>
+              <a:srgbClr val="ECEBE7"/>
+            </a:solidFill>
+          </a:ln>
+          <a:effectLst/>
+        </p:spPr>
+        <p:style>
+          <a:lnRef idx="1">
+            <a:schemeClr val="accent1"/>
+          </a:lnRef>
+          <a:fillRef idx="3">
+            <a:schemeClr val="accent1"/>
+          </a:fillRef>
+          <a:effectRef idx="2">
+            <a:schemeClr val="accent1"/>
+          </a:effectRef>
+          <a:fontRef idx="minor">
+            <a:schemeClr val="lt1"/>
+          </a:fontRef>
+        </p:style>
+        <p:txBody>
+          <a:bodyPr wrap="square" rtlCol="0" anchor="ctr"/>
+          <a:lstStyle/>
+          <a:p>
+            <a:pPr algn="ctr"/>
+            <a:endParaRPr/>
+          </a:p>
+        </p:txBody>
+      </p:sp>
+      <p:sp>
+        <p:nvSpPr>
+          <p:cNvPr id="124" name="TextBox 17"/>
+          <p:cNvSpPr txBox="1"/>
+          <p:nvPr/>
+        </p:nvSpPr>
+        <p:spPr>
+          <a:xfrm>
+            <a:off x="457200" y="2812848"/>
+            <a:ext cx="201168" cy="182880"/>
+          </a:xfrm>
+          <a:prstGeom prst="rect">
+            <a:avLst/>
+          </a:prstGeom>
+          <a:noFill/>
+        </p:spPr>
+        <p:txBody>
+          <a:bodyPr wrap="square" lIns="0" tIns="0" rIns="0" bIns="0">
+            <a:spAutoFit/>
+          </a:bodyPr>
+          <a:lstStyle/>
+          <a:p>
+            <a:r>
+              <a:rPr sz="800" b="0" i="0">
+                <a:solidFill>
+                  <a:srgbClr val="98A2B3"/>
+                </a:solidFill>
+                <a:latin typeface="Inter"/>
+              </a:rPr>
+              <a:t>2</a:t>
+            </a:r>
+          </a:p>
+        </p:txBody>
+      </p:sp>
+      <p:sp>
+        <p:nvSpPr>
+          <p:cNvPr id="125" name="TextBox 18"/>
+          <p:cNvSpPr txBox="1"/>
+          <p:nvPr/>
+        </p:nvSpPr>
+        <p:spPr>
+          <a:xfrm>
+            <a:off x="731520" y="2794560"/>
+            <a:ext cx="2400000" cy="329184"/>
+          </a:xfrm>
+          <a:prstGeom prst="rect">
+            <a:avLst/>
+          </a:prstGeom>
+          <a:noFill/>
+        </p:spPr>
+        <p:txBody>
+          <a:bodyPr wrap="square" lIns="0" tIns="0" rIns="0" bIns="0">
+            <a:spAutoFit/>
+          </a:bodyPr>
+          <a:lstStyle/>
+          <a:p>
+            <a:r>
+              <a:rPr sz="900" b="1" i="0">
+                <a:solidFill>
+                  <a:srgbClr val="0A0A0A"/>
+                </a:solidFill>
+                <a:latin typeface="Inter"/>
+              </a:rPr>
+              <a:t>Marmiton</a:t>
+            </a:r>
+          </a:p>
+        </p:txBody>
+      </p:sp>
+      <p:sp>
+        <p:nvSpPr>
+          <p:cNvPr id="126" name="Rounded Rectangle 24"/>
+          <p:cNvSpPr/>
+          <p:nvPr/>
+        </p:nvSpPr>
+        <p:spPr>
+          <a:xfrm>
+            <a:off x="3337560" y="2864560"/>
+            <a:ext cx="4572000" cy="64008"/>
+          </a:xfrm>
+          <a:prstGeom prst="roundRect">
+            <a:avLst>
+              <a:gd name="adj" fmla="val 50000"/>
+            </a:avLst>
+          </a:prstGeom>
+          <a:solidFill>
+            <a:srgbClr val="EDEBE7"/>
+          </a:solidFill>
+          <a:ln w="12700">
+            <a:solidFill>
+              <a:srgbClr val="EDEBE7"/>
+            </a:solidFill>
+          </a:ln>
+          <a:effectLst/>
+        </p:spPr>
+        <p:style>
+          <a:lnRef idx="1">
+            <a:schemeClr val="accent1"/>
+          </a:lnRef>
+          <a:fillRef idx="3">
+            <a:schemeClr val="accent1"/>
+          </a:fillRef>
+          <a:effectRef idx="2">
+            <a:schemeClr val="accent1"/>
+          </a:effectRef>
+          <a:fontRef idx="minor">
+            <a:schemeClr val="lt1"/>
+          </a:fontRef>
+        </p:style>
+        <p:txBody>
+          <a:bodyPr wrap="square" rtlCol="0" anchor="ctr"/>
+          <a:lstStyle/>
+          <a:p>
+            <a:pPr algn="ctr"/>
+            <a:endParaRPr/>
+          </a:p>
+        </p:txBody>
+      </p:sp>
+      <p:sp>
+        <p:nvSpPr>
+          <p:cNvPr id="127" name="Rounded Rectangle 25"/>
+          <p:cNvSpPr/>
+          <p:nvPr/>
+        </p:nvSpPr>
+        <p:spPr>
+          <a:xfrm>
+            <a:off x="3337560" y="2864560"/>
+            <a:ext cx="3920924" cy="64008"/>
+          </a:xfrm>
+          <a:prstGeom prst="roundRect">
+            <a:avLst>
+              <a:gd name="adj" fmla="val 50000"/>
+            </a:avLst>
+          </a:prstGeom>
+          <a:solidFill>
+            <a:srgbClr val="F6D8C2"/>
+          </a:solidFill>
+          <a:ln w="12700">
+            <a:solidFill>
+              <a:srgbClr val="F6D8C2"/>
+            </a:solidFill>
+          </a:ln>
+          <a:effectLst/>
+        </p:spPr>
+        <p:style>
+          <a:lnRef idx="1">
+            <a:schemeClr val="accent1"/>
+          </a:lnRef>
+          <a:fillRef idx="3">
+            <a:schemeClr val="accent1"/>
+          </a:fillRef>
+          <a:effectRef idx="2">
+            <a:schemeClr val="accent1"/>
+          </a:effectRef>
+          <a:fontRef idx="minor">
+            <a:schemeClr val="lt1"/>
+          </a:fontRef>
+        </p:style>
+        <p:txBody>
+          <a:bodyPr wrap="square" rtlCol="0" anchor="ctr"/>
+          <a:lstStyle/>
+          <a:p>
+            <a:pPr algn="ctr"/>
+            <a:endParaRPr/>
+          </a:p>
+        </p:txBody>
+      </p:sp>
+      <p:sp>
+        <p:nvSpPr>
+          <p:cNvPr id="128" name="TextBox 19"/>
+          <p:cNvSpPr txBox="1"/>
+          <p:nvPr/>
+        </p:nvSpPr>
+        <p:spPr>
+          <a:xfrm>
+            <a:off x="8412480" y="2794560"/>
+            <a:ext cx="914400" cy="201168"/>
+          </a:xfrm>
+          <a:prstGeom prst="rect">
+            <a:avLst/>
+          </a:prstGeom>
+          <a:noFill/>
+        </p:spPr>
+        <p:txBody>
+          <a:bodyPr wrap="square" lIns="0" tIns="0" rIns="0" bIns="0">
+            <a:spAutoFit/>
+          </a:bodyPr>
+          <a:lstStyle/>
+          <a:p>
+            <a:r>
+              <a:rPr sz="900" b="1" i="0">
+                <a:solidFill>
+                  <a:srgbClr val="0A0A0A"/>
+                </a:solidFill>
+                <a:latin typeface="Inter"/>
+              </a:rPr>
+              <a:t>27,1 %</a:t>
+            </a:r>
+          </a:p>
+        </p:txBody>
+      </p:sp>
+      <p:sp>
+        <p:nvSpPr>
+          <p:cNvPr id="129" name="TextBox 22"/>
+          <p:cNvSpPr txBox="1"/>
+          <p:nvPr/>
+        </p:nvSpPr>
+        <p:spPr>
+          <a:xfrm>
+            <a:off x="9601200" y="2794560"/>
+            <a:ext cx="1600000" cy="201168"/>
+          </a:xfrm>
+          <a:prstGeom prst="rect">
+            <a:avLst/>
+          </a:prstGeom>
+          <a:noFill/>
+        </p:spPr>
+        <p:txBody>
+          <a:bodyPr wrap="square" lIns="0" tIns="0" rIns="0" bIns="0">
+            <a:spAutoFit/>
+          </a:bodyPr>
+          <a:lstStyle/>
+          <a:p>
+            <a:r>
+              <a:rPr sz="900" b="1" i="0">
+                <a:solidFill>
+                  <a:srgbClr val="B42318"/>
+                </a:solidFill>
+                <a:latin typeface="Inter"/>
+              </a:rPr>
+              <a:t>▼ -0,1 pt</a:t>
+            </a:r>
+          </a:p>
+        </p:txBody>
+      </p:sp>
+      <p:sp>
+        <p:nvSpPr>
+          <p:cNvPr id="130" name="TextBox 19"/>
+          <p:cNvSpPr txBox="1"/>
+          <p:nvPr/>
+        </p:nvSpPr>
+        <p:spPr>
+          <a:xfrm>
+            <a:off x="10500000" y="2794560"/>
+            <a:ext cx="1100000" cy="201168"/>
+          </a:xfrm>
+          <a:prstGeom prst="rect">
+            <a:avLst/>
+          </a:prstGeom>
+          <a:noFill/>
+        </p:spPr>
+        <p:txBody>
+          <a:bodyPr wrap="square" lIns="0" tIns="0" rIns="0" bIns="0">
+            <a:spAutoFit/>
+          </a:bodyPr>
+          <a:lstStyle/>
+          <a:p>
+            <a:r>
+              <a:rPr sz="900" b="0" i="0">
+                <a:solidFill>
+                  <a:srgbClr val="98A2B3"/>
+                </a:solidFill>
+                <a:latin typeface="Inter"/>
+              </a:rPr>
+              <a:t>vs 27,2 %</a:t>
+            </a:r>
+          </a:p>
+        </p:txBody>
+      </p:sp>
+      <p:sp>
+        <p:nvSpPr>
+          <p:cNvPr id="131" name="Rectangle 16"/>
+          <p:cNvSpPr/>
+          <p:nvPr/>
+        </p:nvSpPr>
+        <p:spPr>
+          <a:xfrm>
+            <a:off x="457200" y="3154560"/>
+            <a:ext cx="11274552" cy="9144"/>
+          </a:xfrm>
+          <a:prstGeom prst="rect">
+            <a:avLst/>
+          </a:prstGeom>
+          <a:solidFill>
+            <a:srgbClr val="ECEBE7"/>
+          </a:solidFill>
+          <a:ln w="12700">
+            <a:solidFill>
+              <a:srgbClr val="ECEBE7"/>
+            </a:solidFill>
+          </a:ln>
+          <a:effectLst/>
+        </p:spPr>
+        <p:style>
+          <a:lnRef idx="1">
+            <a:schemeClr val="accent1"/>
+          </a:lnRef>
+          <a:fillRef idx="3">
+            <a:schemeClr val="accent1"/>
+          </a:fillRef>
+          <a:effectRef idx="2">
+            <a:schemeClr val="accent1"/>
+          </a:effectRef>
+          <a:fontRef idx="minor">
+            <a:schemeClr val="lt1"/>
+          </a:fontRef>
+        </p:style>
+        <p:txBody>
+          <a:bodyPr wrap="square" rtlCol="0" anchor="ctr"/>
+          <a:lstStyle/>
+          <a:p>
+            <a:pPr algn="ctr"/>
+            <a:endParaRPr/>
+          </a:p>
+        </p:txBody>
+      </p:sp>
+      <p:sp>
+        <p:nvSpPr>
+          <p:cNvPr id="132" name="TextBox 17"/>
+          <p:cNvSpPr txBox="1"/>
+          <p:nvPr/>
+        </p:nvSpPr>
+        <p:spPr>
+          <a:xfrm>
+            <a:off x="457200" y="3292848"/>
+            <a:ext cx="201168" cy="182880"/>
+          </a:xfrm>
+          <a:prstGeom prst="rect">
+            <a:avLst/>
+          </a:prstGeom>
+          <a:noFill/>
+        </p:spPr>
+        <p:txBody>
+          <a:bodyPr wrap="square" lIns="0" tIns="0" rIns="0" bIns="0">
+            <a:spAutoFit/>
+          </a:bodyPr>
+          <a:lstStyle/>
+          <a:p>
+            <a:r>
+              <a:rPr sz="800" b="0" i="0">
+                <a:solidFill>
+                  <a:srgbClr val="98A2B3"/>
+                </a:solidFill>
+                <a:latin typeface="Inter"/>
+              </a:rPr>
+              <a:t>3</a:t>
+            </a:r>
+          </a:p>
+        </p:txBody>
+      </p:sp>
+      <p:sp>
+        <p:nvSpPr>
+          <p:cNvPr id="133" name="TextBox 18"/>
+          <p:cNvSpPr txBox="1"/>
+          <p:nvPr/>
+        </p:nvSpPr>
+        <p:spPr>
+          <a:xfrm>
+            <a:off x="731520" y="3274560"/>
+            <a:ext cx="2400000" cy="329184"/>
+          </a:xfrm>
+          <a:prstGeom prst="rect">
+            <a:avLst/>
+          </a:prstGeom>
+          <a:noFill/>
+        </p:spPr>
+        <p:txBody>
+          <a:bodyPr wrap="square" lIns="0" tIns="0" rIns="0" bIns="0">
+            <a:spAutoFit/>
+          </a:bodyPr>
+          <a:lstStyle/>
+          <a:p>
+            <a:r>
+              <a:rPr sz="900" b="1" i="0">
+                <a:solidFill>
+                  <a:srgbClr val="0A0A0A"/>
+                </a:solidFill>
+                <a:latin typeface="Inter"/>
+              </a:rPr>
+              <a:t>Qwant</a:t>
+            </a:r>
+          </a:p>
+        </p:txBody>
+      </p:sp>
+      <p:sp>
+        <p:nvSpPr>
+          <p:cNvPr id="134" name="Rounded Rectangle 24"/>
+          <p:cNvSpPr/>
+          <p:nvPr/>
+        </p:nvSpPr>
+        <p:spPr>
+          <a:xfrm>
+            <a:off x="3337560" y="3344560"/>
+            <a:ext cx="4572000" cy="64008"/>
+          </a:xfrm>
+          <a:prstGeom prst="roundRect">
+            <a:avLst>
+              <a:gd name="adj" fmla="val 50000"/>
+            </a:avLst>
+          </a:prstGeom>
+          <a:solidFill>
+            <a:srgbClr val="EDEBE7"/>
+          </a:solidFill>
+          <a:ln w="12700">
+            <a:solidFill>
+              <a:srgbClr val="EDEBE7"/>
+            </a:solidFill>
+          </a:ln>
+          <a:effectLst/>
+        </p:spPr>
+        <p:style>
+          <a:lnRef idx="1">
+            <a:schemeClr val="accent1"/>
+          </a:lnRef>
+          <a:fillRef idx="3">
+            <a:schemeClr val="accent1"/>
+          </a:fillRef>
+          <a:effectRef idx="2">
+            <a:schemeClr val="accent1"/>
+          </a:effectRef>
+          <a:fontRef idx="minor">
+            <a:schemeClr val="lt1"/>
+          </a:fontRef>
+        </p:style>
+        <p:txBody>
+          <a:bodyPr wrap="square" rtlCol="0" anchor="ctr"/>
+          <a:lstStyle/>
+          <a:p>
+            <a:pPr algn="ctr"/>
+            <a:endParaRPr/>
+          </a:p>
+        </p:txBody>
+      </p:sp>
+      <p:sp>
+        <p:nvSpPr>
+          <p:cNvPr id="135" name="Rounded Rectangle 25"/>
+          <p:cNvSpPr/>
+          <p:nvPr/>
+        </p:nvSpPr>
+        <p:spPr>
+          <a:xfrm>
+            <a:off x="3337560" y="3344560"/>
+            <a:ext cx="2372810" cy="64008"/>
+          </a:xfrm>
+          <a:prstGeom prst="roundRect">
+            <a:avLst>
+              <a:gd name="adj" fmla="val 50000"/>
+            </a:avLst>
+          </a:prstGeom>
+          <a:solidFill>
+            <a:srgbClr val="F6D8C2"/>
+          </a:solidFill>
+          <a:ln w="12700">
+            <a:solidFill>
+              <a:srgbClr val="F6D8C2"/>
+            </a:solidFill>
+          </a:ln>
+          <a:effectLst/>
+        </p:spPr>
+        <p:style>
+          <a:lnRef idx="1">
+            <a:schemeClr val="accent1"/>
+          </a:lnRef>
+          <a:fillRef idx="3">
+            <a:schemeClr val="accent1"/>
+          </a:fillRef>
+          <a:effectRef idx="2">
+            <a:schemeClr val="accent1"/>
+          </a:effectRef>
+          <a:fontRef idx="minor">
+            <a:schemeClr val="lt1"/>
+          </a:fontRef>
+        </p:style>
+        <p:txBody>
+          <a:bodyPr wrap="square" rtlCol="0" anchor="ctr"/>
+          <a:lstStyle/>
+          <a:p>
+            <a:pPr algn="ctr"/>
+            <a:endParaRPr/>
+          </a:p>
+        </p:txBody>
+      </p:sp>
+      <p:sp>
+        <p:nvSpPr>
+          <p:cNvPr id="136" name="TextBox 19"/>
+          <p:cNvSpPr txBox="1"/>
+          <p:nvPr/>
+        </p:nvSpPr>
+        <p:spPr>
+          <a:xfrm>
+            <a:off x="8412480" y="3274560"/>
+            <a:ext cx="914400" cy="201168"/>
+          </a:xfrm>
+          <a:prstGeom prst="rect">
+            <a:avLst/>
+          </a:prstGeom>
+          <a:noFill/>
+        </p:spPr>
+        <p:txBody>
+          <a:bodyPr wrap="square" lIns="0" tIns="0" rIns="0" bIns="0">
+            <a:spAutoFit/>
+          </a:bodyPr>
+          <a:lstStyle/>
+          <a:p>
+            <a:r>
+              <a:rPr sz="900" b="1" i="0">
+                <a:solidFill>
+                  <a:srgbClr val="0A0A0A"/>
+                </a:solidFill>
+                <a:latin typeface="Inter"/>
+              </a:rPr>
+              <a:t>16,4 %</a:t>
+            </a:r>
+          </a:p>
+        </p:txBody>
+      </p:sp>
+      <p:sp>
+        <p:nvSpPr>
+          <p:cNvPr id="137" name="TextBox 22"/>
+          <p:cNvSpPr txBox="1"/>
+          <p:nvPr/>
+        </p:nvSpPr>
+        <p:spPr>
+          <a:xfrm>
+            <a:off x="9601200" y="3274560"/>
+            <a:ext cx="1600000" cy="201168"/>
+          </a:xfrm>
+          <a:prstGeom prst="rect">
+            <a:avLst/>
+          </a:prstGeom>
+          <a:noFill/>
+        </p:spPr>
+        <p:txBody>
+          <a:bodyPr wrap="square" lIns="0" tIns="0" rIns="0" bIns="0">
+            <a:spAutoFit/>
+          </a:bodyPr>
+          <a:lstStyle/>
+          <a:p>
+            <a:r>
+              <a:rPr sz="900" b="1" i="0">
+                <a:solidFill>
+                  <a:srgbClr val="196B24"/>
+                </a:solidFill>
+                <a:latin typeface="Inter"/>
+              </a:rPr>
+              <a:t>▲ +0,1 pt</a:t>
+            </a:r>
+          </a:p>
+        </p:txBody>
+      </p:sp>
+      <p:sp>
+        <p:nvSpPr>
+          <p:cNvPr id="138" name="TextBox 19"/>
+          <p:cNvSpPr txBox="1"/>
+          <p:nvPr/>
+        </p:nvSpPr>
+        <p:spPr>
+          <a:xfrm>
+            <a:off x="10500000" y="3274560"/>
+            <a:ext cx="1100000" cy="201168"/>
+          </a:xfrm>
+          <a:prstGeom prst="rect">
+            <a:avLst/>
+          </a:prstGeom>
+          <a:noFill/>
+        </p:spPr>
+        <p:txBody>
+          <a:bodyPr wrap="square" lIns="0" tIns="0" rIns="0" bIns="0">
+            <a:spAutoFit/>
+          </a:bodyPr>
+          <a:lstStyle/>
+          <a:p>
+            <a:r>
+              <a:rPr sz="900" b="0" i="0">
+                <a:solidFill>
+                  <a:srgbClr val="98A2B3"/>
+                </a:solidFill>
+                <a:latin typeface="Inter"/>
+              </a:rPr>
+              <a:t>vs 16,3 %</a:t>
+            </a:r>
+          </a:p>
+        </p:txBody>
+      </p:sp>
+      <p:sp>
+        <p:nvSpPr>
+          <p:cNvPr id="139" name="Rectangle 16"/>
+          <p:cNvSpPr/>
+          <p:nvPr/>
+        </p:nvSpPr>
+        <p:spPr>
+          <a:xfrm>
+            <a:off x="457200" y="3634560"/>
+            <a:ext cx="11274552" cy="9144"/>
+          </a:xfrm>
+          <a:prstGeom prst="rect">
+            <a:avLst/>
+          </a:prstGeom>
+          <a:solidFill>
+            <a:srgbClr val="ECEBE7"/>
+          </a:solidFill>
+          <a:ln w="12700">
+            <a:solidFill>
+              <a:srgbClr val="ECEBE7"/>
+            </a:solidFill>
+          </a:ln>
+          <a:effectLst/>
+        </p:spPr>
+        <p:style>
+          <a:lnRef idx="1">
+            <a:schemeClr val="accent1"/>
+          </a:lnRef>
+          <a:fillRef idx="3">
+            <a:schemeClr val="accent1"/>
+          </a:fillRef>
+          <a:effectRef idx="2">
+            <a:schemeClr val="accent1"/>
+          </a:effectRef>
+          <a:fontRef idx="minor">
+            <a:schemeClr val="lt1"/>
+          </a:fontRef>
+        </p:style>
+        <p:txBody>
+          <a:bodyPr wrap="square" rtlCol="0" anchor="ctr"/>
+          <a:lstStyle/>
+          <a:p>
+            <a:pPr algn="ctr"/>
+            <a:endParaRPr/>
+          </a:p>
+        </p:txBody>
+      </p:sp>
+      <p:sp>
+        <p:nvSpPr>
+          <p:cNvPr id="140" name="TextBox 17"/>
+          <p:cNvSpPr txBox="1"/>
+          <p:nvPr/>
+        </p:nvSpPr>
+        <p:spPr>
+          <a:xfrm>
+            <a:off x="457200" y="3772848"/>
+            <a:ext cx="201168" cy="182880"/>
+          </a:xfrm>
+          <a:prstGeom prst="rect">
+            <a:avLst/>
+          </a:prstGeom>
+          <a:noFill/>
+        </p:spPr>
+        <p:txBody>
+          <a:bodyPr wrap="square" lIns="0" tIns="0" rIns="0" bIns="0">
+            <a:spAutoFit/>
+          </a:bodyPr>
+          <a:lstStyle/>
+          <a:p>
+            <a:r>
+              <a:rPr sz="800" b="0" i="0">
+                <a:solidFill>
+                  <a:srgbClr val="98A2B3"/>
+                </a:solidFill>
+                <a:latin typeface="Inter"/>
+              </a:rPr>
+              <a:t>4</a:t>
+            </a:r>
+          </a:p>
+        </p:txBody>
+      </p:sp>
+      <p:sp>
+        <p:nvSpPr>
+          <p:cNvPr id="141" name="TextBox 18"/>
+          <p:cNvSpPr txBox="1"/>
+          <p:nvPr/>
+        </p:nvSpPr>
+        <p:spPr>
+          <a:xfrm>
+            <a:off x="731520" y="3754560"/>
+            <a:ext cx="2400000" cy="329184"/>
+          </a:xfrm>
+          <a:prstGeom prst="rect">
+            <a:avLst/>
+          </a:prstGeom>
+          <a:noFill/>
+        </p:spPr>
+        <p:txBody>
+          <a:bodyPr wrap="square" lIns="0" tIns="0" rIns="0" bIns="0">
+            <a:spAutoFit/>
+          </a:bodyPr>
+          <a:lstStyle/>
+          <a:p>
+            <a:r>
+              <a:rPr sz="900" b="1" i="0">
+                <a:solidFill>
+                  <a:srgbClr val="0A0A0A"/>
+                </a:solidFill>
+                <a:latin typeface="Inter"/>
+              </a:rPr>
+              <a:t>20 Minutes</a:t>
+            </a:r>
+          </a:p>
+        </p:txBody>
+      </p:sp>
+      <p:sp>
+        <p:nvSpPr>
+          <p:cNvPr id="142" name="Rounded Rectangle 24"/>
+          <p:cNvSpPr/>
+          <p:nvPr/>
+        </p:nvSpPr>
+        <p:spPr>
+          <a:xfrm>
+            <a:off x="3337560" y="3824560"/>
+            <a:ext cx="4572000" cy="64008"/>
+          </a:xfrm>
+          <a:prstGeom prst="roundRect">
+            <a:avLst>
+              <a:gd name="adj" fmla="val 50000"/>
+            </a:avLst>
+          </a:prstGeom>
+          <a:solidFill>
+            <a:srgbClr val="EDEBE7"/>
+          </a:solidFill>
+          <a:ln w="12700">
+            <a:solidFill>
+              <a:srgbClr val="EDEBE7"/>
+            </a:solidFill>
+          </a:ln>
+          <a:effectLst/>
+        </p:spPr>
+        <p:style>
+          <a:lnRef idx="1">
+            <a:schemeClr val="accent1"/>
+          </a:lnRef>
+          <a:fillRef idx="3">
+            <a:schemeClr val="accent1"/>
+          </a:fillRef>
+          <a:effectRef idx="2">
+            <a:schemeClr val="accent1"/>
+          </a:effectRef>
+          <a:fontRef idx="minor">
+            <a:schemeClr val="lt1"/>
+          </a:fontRef>
+        </p:style>
+        <p:txBody>
+          <a:bodyPr wrap="square" rtlCol="0" anchor="ctr"/>
+          <a:lstStyle/>
+          <a:p>
+            <a:pPr algn="ctr"/>
+            <a:endParaRPr/>
+          </a:p>
+        </p:txBody>
+      </p:sp>
+      <p:sp>
+        <p:nvSpPr>
+          <p:cNvPr id="143" name="Rounded Rectangle 25"/>
+          <p:cNvSpPr/>
+          <p:nvPr/>
+        </p:nvSpPr>
+        <p:spPr>
+          <a:xfrm>
+            <a:off x="3337560" y="3824560"/>
+            <a:ext cx="925974" cy="64008"/>
+          </a:xfrm>
+          <a:prstGeom prst="roundRect">
+            <a:avLst>
+              <a:gd name="adj" fmla="val 50000"/>
+            </a:avLst>
+          </a:prstGeom>
+          <a:solidFill>
+            <a:srgbClr val="F6D8C2"/>
+          </a:solidFill>
+          <a:ln w="12700">
+            <a:solidFill>
+              <a:srgbClr val="F6D8C2"/>
+            </a:solidFill>
+          </a:ln>
+          <a:effectLst/>
+        </p:spPr>
+        <p:style>
+          <a:lnRef idx="1">
+            <a:schemeClr val="accent1"/>
+          </a:lnRef>
+          <a:fillRef idx="3">
+            <a:schemeClr val="accent1"/>
+          </a:fillRef>
+          <a:effectRef idx="2">
+            <a:schemeClr val="accent1"/>
+          </a:effectRef>
+          <a:fontRef idx="minor">
+            <a:schemeClr val="lt1"/>
+          </a:fontRef>
+        </p:style>
+        <p:txBody>
+          <a:bodyPr wrap="square" rtlCol="0" anchor="ctr"/>
+          <a:lstStyle/>
+          <a:p>
+            <a:pPr algn="ctr"/>
+            <a:endParaRPr/>
+          </a:p>
+        </p:txBody>
+      </p:sp>
+      <p:sp>
+        <p:nvSpPr>
+          <p:cNvPr id="144" name="TextBox 19"/>
+          <p:cNvSpPr txBox="1"/>
+          <p:nvPr/>
+        </p:nvSpPr>
+        <p:spPr>
+          <a:xfrm>
+            <a:off x="8412480" y="3754560"/>
+            <a:ext cx="914400" cy="201168"/>
+          </a:xfrm>
+          <a:prstGeom prst="rect">
+            <a:avLst/>
+          </a:prstGeom>
+          <a:noFill/>
+        </p:spPr>
+        <p:txBody>
+          <a:bodyPr wrap="square" lIns="0" tIns="0" rIns="0" bIns="0">
+            <a:spAutoFit/>
+          </a:bodyPr>
+          <a:lstStyle/>
+          <a:p>
+            <a:r>
+              <a:rPr sz="900" b="1" i="0">
+                <a:solidFill>
+                  <a:srgbClr val="0A0A0A"/>
+                </a:solidFill>
+                <a:latin typeface="Inter"/>
+              </a:rPr>
+              <a:t>6,4 %</a:t>
+            </a:r>
+          </a:p>
+        </p:txBody>
+      </p:sp>
+      <p:sp>
+        <p:nvSpPr>
+          <p:cNvPr id="145" name="TextBox 22"/>
+          <p:cNvSpPr txBox="1"/>
+          <p:nvPr/>
+        </p:nvSpPr>
+        <p:spPr>
+          <a:xfrm>
+            <a:off x="9601200" y="3754560"/>
+            <a:ext cx="1600000" cy="201168"/>
+          </a:xfrm>
+          <a:prstGeom prst="rect">
+            <a:avLst/>
+          </a:prstGeom>
+          <a:noFill/>
+        </p:spPr>
+        <p:txBody>
+          <a:bodyPr wrap="square" lIns="0" tIns="0" rIns="0" bIns="0">
+            <a:spAutoFit/>
+          </a:bodyPr>
+          <a:lstStyle/>
+          <a:p>
+            <a:r>
+              <a:rPr sz="900" b="1" i="0">
+                <a:solidFill>
+                  <a:srgbClr val="B42318"/>
+                </a:solidFill>
+                <a:latin typeface="Inter"/>
+              </a:rPr>
+              <a:t>▼ -0,1 pt</a:t>
+            </a:r>
+          </a:p>
+        </p:txBody>
+      </p:sp>
+      <p:sp>
+        <p:nvSpPr>
+          <p:cNvPr id="146" name="TextBox 19"/>
+          <p:cNvSpPr txBox="1"/>
+          <p:nvPr/>
+        </p:nvSpPr>
+        <p:spPr>
+          <a:xfrm>
+            <a:off x="10500000" y="3754560"/>
+            <a:ext cx="1100000" cy="201168"/>
+          </a:xfrm>
+          <a:prstGeom prst="rect">
+            <a:avLst/>
+          </a:prstGeom>
+          <a:noFill/>
+        </p:spPr>
+        <p:txBody>
+          <a:bodyPr wrap="square" lIns="0" tIns="0" rIns="0" bIns="0">
+            <a:spAutoFit/>
+          </a:bodyPr>
+          <a:lstStyle/>
+          <a:p>
+            <a:r>
+              <a:rPr sz="900" b="0" i="0">
+                <a:solidFill>
+                  <a:srgbClr val="98A2B3"/>
+                </a:solidFill>
+                <a:latin typeface="Inter"/>
+              </a:rPr>
+              <a:t>vs 6,5 %</a:t>
+            </a:r>
+          </a:p>
+        </p:txBody>
+      </p:sp>
+      <p:sp>
+        <p:nvSpPr>
+          <p:cNvPr id="147" name="Rectangle 16"/>
+          <p:cNvSpPr/>
+          <p:nvPr/>
+        </p:nvSpPr>
+        <p:spPr>
+          <a:xfrm>
+            <a:off x="457200" y="4114560"/>
+            <a:ext cx="11274552" cy="9144"/>
+          </a:xfrm>
+          <a:prstGeom prst="rect">
+            <a:avLst/>
+          </a:prstGeom>
+          <a:solidFill>
+            <a:srgbClr val="ECEBE7"/>
+          </a:solidFill>
+          <a:ln w="12700">
+            <a:solidFill>
+              <a:srgbClr val="ECEBE7"/>
+            </a:solidFill>
+          </a:ln>
+          <a:effectLst/>
+        </p:spPr>
+        <p:style>
+          <a:lnRef idx="1">
+            <a:schemeClr val="accent1"/>
+          </a:lnRef>
+          <a:fillRef idx="3">
+            <a:schemeClr val="accent1"/>
+          </a:fillRef>
+          <a:effectRef idx="2">
+            <a:schemeClr val="accent1"/>
+          </a:effectRef>
+          <a:fontRef idx="minor">
+            <a:schemeClr val="lt1"/>
+          </a:fontRef>
+        </p:style>
+        <p:txBody>
+          <a:bodyPr wrap="square" rtlCol="0" anchor="ctr"/>
+          <a:lstStyle/>
+          <a:p>
+            <a:pPr algn="ctr"/>
+            <a:endParaRPr/>
+          </a:p>
+        </p:txBody>
+      </p:sp>
+      <p:sp>
+        <p:nvSpPr>
+          <p:cNvPr id="148" name="TextBox 17"/>
+          <p:cNvSpPr txBox="1"/>
+          <p:nvPr/>
+        </p:nvSpPr>
+        <p:spPr>
+          <a:xfrm>
+            <a:off x="457200" y="4252848"/>
+            <a:ext cx="201168" cy="182880"/>
+          </a:xfrm>
+          <a:prstGeom prst="rect">
+            <a:avLst/>
+          </a:prstGeom>
+          <a:noFill/>
+        </p:spPr>
+        <p:txBody>
+          <a:bodyPr wrap="square" lIns="0" tIns="0" rIns="0" bIns="0">
+            <a:spAutoFit/>
+          </a:bodyPr>
+          <a:lstStyle/>
+          <a:p>
+            <a:r>
+              <a:rPr sz="800" b="0" i="0">
+                <a:solidFill>
+                  <a:srgbClr val="98A2B3"/>
+                </a:solidFill>
+                <a:latin typeface="Inter"/>
+              </a:rPr>
+              <a:t>5</a:t>
+            </a:r>
+          </a:p>
+        </p:txBody>
+      </p:sp>
+      <p:sp>
+        <p:nvSpPr>
+          <p:cNvPr id="149" name="TextBox 18"/>
+          <p:cNvSpPr txBox="1"/>
+          <p:nvPr/>
+        </p:nvSpPr>
+        <p:spPr>
+          <a:xfrm>
+            <a:off x="731520" y="4234560"/>
+            <a:ext cx="2400000" cy="329184"/>
+          </a:xfrm>
+          <a:prstGeom prst="rect">
+            <a:avLst/>
+          </a:prstGeom>
+          <a:noFill/>
+        </p:spPr>
+        <p:txBody>
+          <a:bodyPr wrap="square" lIns="0" tIns="0" rIns="0" bIns="0">
+            <a:spAutoFit/>
+          </a:bodyPr>
+          <a:lstStyle/>
+          <a:p>
+            <a:r>
+              <a:rPr sz="900" b="1" i="0">
+                <a:solidFill>
+                  <a:srgbClr val="0A0A0A"/>
+                </a:solidFill>
+                <a:latin typeface="Inter"/>
+              </a:rPr>
+              <a:t>Biba</a:t>
+            </a:r>
+          </a:p>
+        </p:txBody>
+      </p:sp>
+      <p:sp>
+        <p:nvSpPr>
+          <p:cNvPr id="150" name="Rounded Rectangle 24"/>
+          <p:cNvSpPr/>
+          <p:nvPr/>
+        </p:nvSpPr>
+        <p:spPr>
+          <a:xfrm>
+            <a:off x="3337560" y="4304560"/>
+            <a:ext cx="4572000" cy="64008"/>
+          </a:xfrm>
+          <a:prstGeom prst="roundRect">
+            <a:avLst>
+              <a:gd name="adj" fmla="val 50000"/>
+            </a:avLst>
+          </a:prstGeom>
+          <a:solidFill>
+            <a:srgbClr val="EDEBE7"/>
+          </a:solidFill>
+          <a:ln w="12700">
+            <a:solidFill>
+              <a:srgbClr val="EDEBE7"/>
+            </a:solidFill>
+          </a:ln>
+          <a:effectLst/>
+        </p:spPr>
+        <p:style>
+          <a:lnRef idx="1">
+            <a:schemeClr val="accent1"/>
+          </a:lnRef>
+          <a:fillRef idx="3">
+            <a:schemeClr val="accent1"/>
+          </a:fillRef>
+          <a:effectRef idx="2">
+            <a:schemeClr val="accent1"/>
+          </a:effectRef>
+          <a:fontRef idx="minor">
+            <a:schemeClr val="lt1"/>
+          </a:fontRef>
+        </p:style>
+        <p:txBody>
+          <a:bodyPr wrap="square" rtlCol="0" anchor="ctr"/>
+          <a:lstStyle/>
+          <a:p>
+            <a:pPr algn="ctr"/>
+            <a:endParaRPr/>
+          </a:p>
+        </p:txBody>
+      </p:sp>
+      <p:sp>
+        <p:nvSpPr>
+          <p:cNvPr id="151" name="Rounded Rectangle 25"/>
+          <p:cNvSpPr/>
+          <p:nvPr/>
+        </p:nvSpPr>
+        <p:spPr>
+          <a:xfrm>
+            <a:off x="3337560" y="4304560"/>
+            <a:ext cx="911506" cy="64008"/>
+          </a:xfrm>
+          <a:prstGeom prst="roundRect">
+            <a:avLst>
+              <a:gd name="adj" fmla="val 50000"/>
+            </a:avLst>
+          </a:prstGeom>
+          <a:solidFill>
+            <a:srgbClr val="F6D8C2"/>
+          </a:solidFill>
+          <a:ln w="12700">
+            <a:solidFill>
+              <a:srgbClr val="F6D8C2"/>
+            </a:solidFill>
+          </a:ln>
+          <a:effectLst/>
+        </p:spPr>
+        <p:style>
+          <a:lnRef idx="1">
+            <a:schemeClr val="accent1"/>
+          </a:lnRef>
+          <a:fillRef idx="3">
+            <a:schemeClr val="accent1"/>
+          </a:fillRef>
+          <a:effectRef idx="2">
+            <a:schemeClr val="accent1"/>
+          </a:effectRef>
+          <a:fontRef idx="minor">
+            <a:schemeClr val="lt1"/>
+          </a:fontRef>
+        </p:style>
+        <p:txBody>
+          <a:bodyPr wrap="square" rtlCol="0" anchor="ctr"/>
+          <a:lstStyle/>
+          <a:p>
+            <a:pPr algn="ctr"/>
+            <a:endParaRPr/>
+          </a:p>
+        </p:txBody>
+      </p:sp>
+      <p:sp>
+        <p:nvSpPr>
+          <p:cNvPr id="152" name="TextBox 19"/>
+          <p:cNvSpPr txBox="1"/>
+          <p:nvPr/>
+        </p:nvSpPr>
+        <p:spPr>
+          <a:xfrm>
+            <a:off x="8412480" y="4234560"/>
+            <a:ext cx="914400" cy="201168"/>
+          </a:xfrm>
+          <a:prstGeom prst="rect">
+            <a:avLst/>
+          </a:prstGeom>
+          <a:noFill/>
+        </p:spPr>
+        <p:txBody>
+          <a:bodyPr wrap="square" lIns="0" tIns="0" rIns="0" bIns="0">
+            <a:spAutoFit/>
+          </a:bodyPr>
+          <a:lstStyle/>
+          <a:p>
+            <a:r>
+              <a:rPr sz="900" b="1" i="0">
+                <a:solidFill>
+                  <a:srgbClr val="0A0A0A"/>
+                </a:solidFill>
+                <a:latin typeface="Inter"/>
+              </a:rPr>
+              <a:t>6,3 %</a:t>
+            </a:r>
+          </a:p>
+        </p:txBody>
+      </p:sp>
+      <p:sp>
+        <p:nvSpPr>
+          <p:cNvPr id="153" name="TextBox 22"/>
+          <p:cNvSpPr txBox="1"/>
+          <p:nvPr/>
+        </p:nvSpPr>
+        <p:spPr>
+          <a:xfrm>
+            <a:off x="9601200" y="4234560"/>
+            <a:ext cx="1600000" cy="201168"/>
+          </a:xfrm>
+          <a:prstGeom prst="rect">
+            <a:avLst/>
+          </a:prstGeom>
+          <a:noFill/>
+        </p:spPr>
+        <p:txBody>
+          <a:bodyPr wrap="square" lIns="0" tIns="0" rIns="0" bIns="0">
+            <a:spAutoFit/>
+          </a:bodyPr>
+          <a:lstStyle/>
+          <a:p>
+            <a:r>
+              <a:rPr sz="900" b="1" i="0">
+                <a:solidFill>
+                  <a:srgbClr val="196B24"/>
+                </a:solidFill>
+                <a:latin typeface="Inter"/>
+              </a:rPr>
+              <a:t>▲ +0,1 pt</a:t>
+            </a:r>
+          </a:p>
+        </p:txBody>
+      </p:sp>
+      <p:sp>
+        <p:nvSpPr>
+          <p:cNvPr id="154" name="TextBox 19"/>
+          <p:cNvSpPr txBox="1"/>
+          <p:nvPr/>
+        </p:nvSpPr>
+        <p:spPr>
+          <a:xfrm>
+            <a:off x="10500000" y="4234560"/>
+            <a:ext cx="1100000" cy="201168"/>
+          </a:xfrm>
+          <a:prstGeom prst="rect">
+            <a:avLst/>
+          </a:prstGeom>
+          <a:noFill/>
+        </p:spPr>
+        <p:txBody>
+          <a:bodyPr wrap="square" lIns="0" tIns="0" rIns="0" bIns="0">
+            <a:spAutoFit/>
+          </a:bodyPr>
+          <a:lstStyle/>
+          <a:p>
+            <a:r>
+              <a:rPr sz="900" b="0" i="0">
+                <a:solidFill>
+                  <a:srgbClr val="98A2B3"/>
+                </a:solidFill>
+                <a:latin typeface="Inter"/>
+              </a:rPr>
+              <a:t>vs 6,2 %</a:t>
+            </a:r>
+          </a:p>
+        </p:txBody>
+      </p:sp>
+      <p:sp>
+        <p:nvSpPr>
+          <p:cNvPr id="155" name="Rectangle 16"/>
+          <p:cNvSpPr/>
+          <p:nvPr/>
+        </p:nvSpPr>
+        <p:spPr>
+          <a:xfrm>
+            <a:off x="457200" y="4594560"/>
+            <a:ext cx="11274552" cy="9144"/>
+          </a:xfrm>
+          <a:prstGeom prst="rect">
+            <a:avLst/>
+          </a:prstGeom>
+          <a:solidFill>
+            <a:srgbClr val="ECEBE7"/>
+          </a:solidFill>
+          <a:ln w="12700">
+            <a:solidFill>
+              <a:srgbClr val="ECEBE7"/>
+            </a:solidFill>
+          </a:ln>
+          <a:effectLst/>
+        </p:spPr>
+        <p:style>
+          <a:lnRef idx="1">
+            <a:schemeClr val="accent1"/>
+          </a:lnRef>
+          <a:fillRef idx="3">
+            <a:schemeClr val="accent1"/>
+          </a:fillRef>
+          <a:effectRef idx="2">
+            <a:schemeClr val="accent1"/>
+          </a:effectRef>
+          <a:fontRef idx="minor">
+            <a:schemeClr val="lt1"/>
+          </a:fontRef>
+        </p:style>
+        <p:txBody>
+          <a:bodyPr wrap="square" rtlCol="0" anchor="ctr"/>
+          <a:lstStyle/>
+          <a:p>
+            <a:pPr algn="ctr"/>
+            <a:endParaRPr/>
+          </a:p>
+        </p:txBody>
+      </p:sp>
+      <p:sp>
+        <p:nvSpPr>
+          <p:cNvPr id="156" name="TextBox 17"/>
+          <p:cNvSpPr txBox="1"/>
+          <p:nvPr/>
+        </p:nvSpPr>
+        <p:spPr>
+          <a:xfrm>
+            <a:off x="457200" y="4732848"/>
+            <a:ext cx="201168" cy="182880"/>
+          </a:xfrm>
+          <a:prstGeom prst="rect">
+            <a:avLst/>
+          </a:prstGeom>
+          <a:noFill/>
+        </p:spPr>
+        <p:txBody>
+          <a:bodyPr wrap="square" lIns="0" tIns="0" rIns="0" bIns="0">
+            <a:spAutoFit/>
+          </a:bodyPr>
+          <a:lstStyle/>
+          <a:p>
+            <a:r>
+              <a:rPr sz="800" b="0" i="0">
+                <a:solidFill>
+                  <a:srgbClr val="98A2B3"/>
+                </a:solidFill>
+                <a:latin typeface="Inter"/>
+              </a:rPr>
+              <a:t>6</a:t>
+            </a:r>
+          </a:p>
+        </p:txBody>
+      </p:sp>
+      <p:sp>
+        <p:nvSpPr>
+          <p:cNvPr id="157" name="TextBox 18"/>
+          <p:cNvSpPr txBox="1"/>
+          <p:nvPr/>
+        </p:nvSpPr>
+        <p:spPr>
+          <a:xfrm>
+            <a:off x="731520" y="4714560"/>
+            <a:ext cx="2400000" cy="329184"/>
+          </a:xfrm>
+          <a:prstGeom prst="rect">
+            <a:avLst/>
+          </a:prstGeom>
+          <a:noFill/>
+        </p:spPr>
+        <p:txBody>
+          <a:bodyPr wrap="square" lIns="0" tIns="0" rIns="0" bIns="0">
+            <a:spAutoFit/>
+          </a:bodyPr>
+          <a:lstStyle/>
+          <a:p>
+            <a:r>
+              <a:rPr sz="900" b="1" i="0">
+                <a:solidFill>
+                  <a:srgbClr val="0A0A0A"/>
+                </a:solidFill>
+                <a:latin typeface="Inter"/>
+              </a:rPr>
+              <a:t>Autres</a:t>
+            </a:r>
+          </a:p>
+        </p:txBody>
+      </p:sp>
+      <p:sp>
+        <p:nvSpPr>
+          <p:cNvPr id="158" name="Rounded Rectangle 24"/>
+          <p:cNvSpPr/>
+          <p:nvPr/>
+        </p:nvSpPr>
+        <p:spPr>
+          <a:xfrm>
+            <a:off x="3337560" y="4784560"/>
+            <a:ext cx="4572000" cy="64008"/>
+          </a:xfrm>
+          <a:prstGeom prst="roundRect">
+            <a:avLst>
+              <a:gd name="adj" fmla="val 50000"/>
+            </a:avLst>
+          </a:prstGeom>
+          <a:solidFill>
+            <a:srgbClr val="EDEBE7"/>
+          </a:solidFill>
+          <a:ln w="12700">
+            <a:solidFill>
+              <a:srgbClr val="EDEBE7"/>
+            </a:solidFill>
+          </a:ln>
+          <a:effectLst/>
+        </p:spPr>
+        <p:style>
+          <a:lnRef idx="1">
+            <a:schemeClr val="accent1"/>
+          </a:lnRef>
+          <a:fillRef idx="3">
+            <a:schemeClr val="accent1"/>
+          </a:fillRef>
+          <a:effectRef idx="2">
+            <a:schemeClr val="accent1"/>
+          </a:effectRef>
+          <a:fontRef idx="minor">
+            <a:schemeClr val="lt1"/>
+          </a:fontRef>
+        </p:style>
+        <p:txBody>
+          <a:bodyPr wrap="square" rtlCol="0" anchor="ctr"/>
+          <a:lstStyle/>
+          <a:p>
+            <a:pPr algn="ctr"/>
+            <a:endParaRPr/>
+          </a:p>
+        </p:txBody>
+      </p:sp>
+      <p:sp>
+        <p:nvSpPr>
+          <p:cNvPr id="159" name="Rounded Rectangle 25"/>
+          <p:cNvSpPr/>
+          <p:nvPr/>
+        </p:nvSpPr>
+        <p:spPr>
+          <a:xfrm>
+            <a:off x="3337560" y="4784560"/>
+            <a:ext cx="1765139" cy="64008"/>
+          </a:xfrm>
+          <a:prstGeom prst="roundRect">
+            <a:avLst>
+              <a:gd name="adj" fmla="val 50000"/>
+            </a:avLst>
+          </a:prstGeom>
+          <a:solidFill>
+            <a:srgbClr val="F6D8C2"/>
+          </a:solidFill>
+          <a:ln w="12700">
+            <a:solidFill>
+              <a:srgbClr val="F6D8C2"/>
+            </a:solidFill>
+          </a:ln>
+          <a:effectLst/>
+        </p:spPr>
+        <p:style>
+          <a:lnRef idx="1">
+            <a:schemeClr val="accent1"/>
+          </a:lnRef>
+          <a:fillRef idx="3">
+            <a:schemeClr val="accent1"/>
+          </a:fillRef>
+          <a:effectRef idx="2">
+            <a:schemeClr val="accent1"/>
+          </a:effectRef>
+          <a:fontRef idx="minor">
+            <a:schemeClr val="lt1"/>
+          </a:fontRef>
+        </p:style>
+        <p:txBody>
+          <a:bodyPr wrap="square" rtlCol="0" anchor="ctr"/>
+          <a:lstStyle/>
+          <a:p>
+            <a:pPr algn="ctr"/>
+            <a:endParaRPr/>
+          </a:p>
+        </p:txBody>
+      </p:sp>
+      <p:sp>
+        <p:nvSpPr>
+          <p:cNvPr id="160" name="TextBox 19"/>
+          <p:cNvSpPr txBox="1"/>
+          <p:nvPr/>
+        </p:nvSpPr>
+        <p:spPr>
+          <a:xfrm>
+            <a:off x="8412480" y="4714560"/>
+            <a:ext cx="914400" cy="201168"/>
+          </a:xfrm>
+          <a:prstGeom prst="rect">
+            <a:avLst/>
+          </a:prstGeom>
+          <a:noFill/>
+        </p:spPr>
+        <p:txBody>
+          <a:bodyPr wrap="square" lIns="0" tIns="0" rIns="0" bIns="0">
+            <a:spAutoFit/>
+          </a:bodyPr>
+          <a:lstStyle/>
+          <a:p>
+            <a:r>
+              <a:rPr sz="900" b="1" i="0">
+                <a:solidFill>
+                  <a:srgbClr val="0A0A0A"/>
+                </a:solidFill>
+                <a:latin typeface="Inter"/>
+              </a:rPr>
+              <a:t>12,2 %</a:t>
+            </a:r>
+          </a:p>
+        </p:txBody>
+      </p:sp>
+      <p:sp>
+        <p:nvSpPr>
+          <p:cNvPr id="161" name="TextBox 22"/>
+          <p:cNvSpPr txBox="1"/>
+          <p:nvPr/>
+        </p:nvSpPr>
+        <p:spPr>
+          <a:xfrm>
+            <a:off x="9601200" y="4714560"/>
+            <a:ext cx="1600000" cy="201168"/>
+          </a:xfrm>
+          <a:prstGeom prst="rect">
+            <a:avLst/>
+          </a:prstGeom>
+          <a:noFill/>
+        </p:spPr>
+        <p:txBody>
+          <a:bodyPr wrap="square" lIns="0" tIns="0" rIns="0" bIns="0">
+            <a:spAutoFit/>
+          </a:bodyPr>
+          <a:lstStyle/>
+          <a:p>
+            <a:r>
+              <a:rPr sz="900" b="1" i="0">
+                <a:solidFill>
+                  <a:srgbClr val="B42318"/>
+                </a:solidFill>
+                <a:latin typeface="Inter"/>
+              </a:rPr>
+              <a:t>▼ -0,3 pt</a:t>
+            </a:r>
+          </a:p>
+        </p:txBody>
+      </p:sp>
+      <p:sp>
+        <p:nvSpPr>
+          <p:cNvPr id="162" name="TextBox 19"/>
+          <p:cNvSpPr txBox="1"/>
+          <p:nvPr/>
+        </p:nvSpPr>
+        <p:spPr>
+          <a:xfrm>
+            <a:off x="10500000" y="4714560"/>
+            <a:ext cx="1100000" cy="201168"/>
+          </a:xfrm>
+          <a:prstGeom prst="rect">
+            <a:avLst/>
+          </a:prstGeom>
+          <a:noFill/>
+        </p:spPr>
+        <p:txBody>
+          <a:bodyPr wrap="square" lIns="0" tIns="0" rIns="0" bIns="0">
+            <a:spAutoFit/>
+          </a:bodyPr>
+          <a:lstStyle/>
+          <a:p>
+            <a:r>
+              <a:rPr sz="900" b="0" i="0">
+                <a:solidFill>
+                  <a:srgbClr val="98A2B3"/>
+                </a:solidFill>
+                <a:latin typeface="Inter"/>
+              </a:rPr>
+              <a:t>vs 12,5 %</a:t>
+            </a:r>
+          </a:p>
+        </p:txBody>
+      </p:sp>
+      <p:sp>
+        <p:nvSpPr>
+          <p:cNvPr id="163" name="Rectangle 16"/>
+          <p:cNvSpPr/>
+          <p:nvPr/>
+        </p:nvSpPr>
+        <p:spPr>
+          <a:xfrm>
+            <a:off x="457200" y="5074560"/>
+            <a:ext cx="11274552" cy="9144"/>
+          </a:xfrm>
+          <a:prstGeom prst="rect">
+            <a:avLst/>
+          </a:prstGeom>
+          <a:solidFill>
+            <a:srgbClr val="ECEBE7"/>
+          </a:solidFill>
+          <a:ln w="12700">
+            <a:solidFill>
+              <a:srgbClr val="ECEBE7"/>
+            </a:solidFill>
+          </a:ln>
+          <a:effectLst/>
+        </p:spPr>
+        <p:style>
+          <a:lnRef idx="1">
+            <a:schemeClr val="accent1"/>
+          </a:lnRef>
+          <a:fillRef idx="3">
+            <a:schemeClr val="accent1"/>
+          </a:fillRef>
+          <a:effectRef idx="2">
+            <a:schemeClr val="accent1"/>
+          </a:effectRef>
+          <a:fontRef idx="minor">
+            <a:schemeClr val="lt1"/>
+          </a:fontRef>
+        </p:style>
+        <p:txBody>
+          <a:bodyPr wrap="square" rtlCol="0" anchor="ctr"/>
+          <a:lstStyle/>
+          <a:p>
+            <a:pPr algn="ctr"/>
+            <a:endParaRPr/>
+          </a:p>
+        </p:txBody>
+      </p:sp>
+      <p:sp>
+        <p:nvSpPr>
+          <p:cNvPr id="164" name="Rectangle 129"/>
+          <p:cNvSpPr/>
+          <p:nvPr/>
+        </p:nvSpPr>
+        <p:spPr>
+          <a:xfrm>
+            <a:off x="457200" y="6035040"/>
+            <a:ext cx="11274552" cy="749808"/>
+          </a:xfrm>
+          <a:prstGeom prst="rect">
+            <a:avLst/>
+          </a:prstGeom>
+          <a:solidFill>
+            <a:srgbClr val="F7F6F4"/>
+          </a:solidFill>
+          <a:ln w="12700">
+            <a:solidFill>
+              <a:srgbClr val="F7F6F4"/>
+            </a:solidFill>
+          </a:ln>
+          <a:effectLst/>
+        </p:spPr>
+        <p:style>
+          <a:lnRef idx="1">
+            <a:schemeClr val="accent1"/>
+          </a:lnRef>
+          <a:fillRef idx="3">
+            <a:schemeClr val="accent1"/>
+          </a:fillRef>
+          <a:effectRef idx="2">
+            <a:schemeClr val="accent1"/>
+          </a:effectRef>
+          <a:fontRef idx="minor">
+            <a:schemeClr val="lt1"/>
+          </a:fontRef>
+        </p:style>
+        <p:txBody>
+          <a:bodyPr wrap="square" rtlCol="0" anchor="ctr"/>
+          <a:lstStyle/>
+          <a:p>
+            <a:pPr algn="ctr"/>
+            <a:endParaRPr/>
+          </a:p>
+        </p:txBody>
+      </p:sp>
+      <p:sp>
+        <p:nvSpPr>
+          <p:cNvPr id="165" name="TextBox 130"/>
+          <p:cNvSpPr txBox="1"/>
+          <p:nvPr/>
+        </p:nvSpPr>
+        <p:spPr>
+          <a:xfrm>
+            <a:off x="640080" y="6132945"/>
+            <a:ext cx="10972800" cy="553998"/>
+          </a:xfrm>
+          <a:prstGeom prst="rect">
+            <a:avLst/>
+          </a:prstGeom>
+          <a:noFill/>
+        </p:spPr>
+        <p:txBody>
+          <a:bodyPr wrap="square" lIns="0" tIns="0" rIns="0" bIns="0" anchor="ctr">
+            <a:spAutoFit/>
+          </a:bodyPr>
+          <a:lstStyle/>
+          <a:p>
+            <a:r>
+              <a:rPr lang="fr-FR" sz="900" b="1"/>
+              <a:t>À retenir. </a:t>
+            </a:r>
+            <a:r>
+              <a:rPr lang="fr-FR" sz="900"/>
+              <a:t>La répartition reste stable : aucun média ne bouge de plus de 0,3 point et le classement est inchangé.</a:t>
+            </a:r>
+          </a:p>
+          <a:p>
+            <a:r>
+              <a:rPr lang="fr-FR" sz="900"/>
+              <a:t>Modes &amp; Travaux renforce sa première place : 31,6 % des impressions, +0,3 point.</a:t>
+            </a:r>
+          </a:p>
+          <a:p>
+            <a:r>
+              <a:rPr lang="fr-FR" sz="900"/>
+              <a:t>Avec Marmiton (27,1 %) et Qwant (16,4 %), les trois premiers médias portent 75,1 % de la diffusion.</a:t>
+            </a:r>
+          </a:p>
+          <a:p>
+            <a:r>
+              <a:rPr lang="fr-FR" sz="900"/>
+              <a:t>20 Minutes (6,4 %) et Biba (6,3 %) se resserrent ; la longue traîne des autres médias recule de 0,3 point, à 12,2 %.</a:t>
+            </a:r>
+          </a:p>
+        </p:txBody>
+      </p:sp>
+      <p:sp>
+        <p:nvSpPr>
+          <p:cNvPr id="166" name="TextBox 131"/>
+          <p:cNvSpPr txBox="1"/>
+          <p:nvPr/>
+        </p:nvSpPr>
+        <p:spPr>
+          <a:xfrm>
+            <a:off x="457200" y="118872"/>
+            <a:ext cx="9144000" cy="201168"/>
+          </a:xfrm>
+          <a:prstGeom prst="rect">
+            <a:avLst/>
+          </a:prstGeom>
+          <a:noFill/>
+        </p:spPr>
+        <p:txBody>
+          <a:bodyPr wrap="square" lIns="0" tIns="0" rIns="0" bIns="0">
+            <a:spAutoFit/>
+          </a:bodyPr>
+          <a:lstStyle/>
+          <a:p>
+            <a:r>
+              <a:rPr sz="700" b="0" i="0" spc="110">
+                <a:solidFill>
+                  <a:srgbClr val="A8A49C"/>
+                </a:solidFill>
+                <a:latin typeface="Inter"/>
+              </a:rPr>
+              <a:t>01 INDICATEURS</a:t>
+            </a:r>
+            <a:r>
+              <a:rPr sz="700" b="0" i="0" spc="110">
+                <a:solidFill>
+                  <a:srgbClr val="C9C6C0"/>
+                </a:solidFill>
+                <a:latin typeface="Inter"/>
+              </a:rPr>
+              <a:t>   ·   </a:t>
+            </a:r>
+            <a:r>
+              <a:rPr sz="700" b="1" i="0" spc="110">
+                <a:solidFill>
+                  <a:srgbClr val="F26B2A"/>
+                </a:solidFill>
+                <a:latin typeface="Inter"/>
+              </a:rPr>
+              <a:t>02 BOULANGER</a:t>
+            </a:r>
+            <a:r>
+              <a:rPr sz="700" b="0" i="0" spc="110">
+                <a:solidFill>
+                  <a:srgbClr val="C9C6C0"/>
+                </a:solidFill>
+                <a:latin typeface="Inter"/>
+              </a:rPr>
+              <a:t>   ·   </a:t>
+            </a:r>
+            <a:r>
+              <a:rPr sz="700" b="0" i="0" spc="110">
+                <a:solidFill>
+                  <a:srgbClr val="A8A49C"/>
                 </a:solidFill>
                 <a:latin typeface="Inter"/>
               </a:rPr>

</xml_diff>